<commit_message>
Density pass on Weeks 5, 10, 11, 14; mark build complete
Adds reusable format specifications, second-language register guidance
and an over-specification corrective to Week 5; a clinical worked example,
three scoping mistakes and the no-documents case to Week 10; a written-out
Domain Pack and glossary-recall technique to Week 11; a course timeline,
six-question self-check and answers to Week 14.

Final state: 14 decks, 295 slides, 43,336 words of verbatim script, notes
on every slide. 8 assessment papers, 160 questions, all compiling.

Co-Authored-By: Claude Opus 5 <noreply@anthropic.com>
</commit_message>
<xml_diff>
--- a/Lectures/week05/week05.pptx
+++ b/Lectures/week05/week05.pptx
@@ -25,6 +25,9 @@
     <p:sldId id="273" r:id="rId25"/>
     <p:sldId id="274" r:id="rId26"/>
     <p:sldId id="275" r:id="rId27"/>
+    <p:sldId id="276" r:id="rId28"/>
+    <p:sldId id="277" r:id="rId29"/>
+    <p:sldId id="278" r:id="rId30"/>
   </p:sldIdLst>
   <p:sldSz cx="12191695" cy="6858000" type="screen4x3"/>
   <p:notesSz cx="6858000" cy="9144000"/>
@@ -1315,93 +1318,87 @@
           <a:lstStyle/>
           <a:p>
             <a:r>
-              <a:t>Here's a need that comes up constantly in professional work: the same content, correctly</a:t>
-            </a:r>
-          </a:p>
-          <a:p>
-            <a:r>
-              <a:t>pitched to different readers.</a:t>
+              <a:t>Three format specifications you can steal today. I use all three regularly and they cover most</a:t>
+            </a:r>
+          </a:p>
+          <a:p>
+            <a:r>
+              <a:t>professional situations.</a:t>
             </a:r>
           </a:p>
           <a:p/>
           <a:p>
             <a:r>
-              <a:t>A clinical finding goes into the notes, into a referral letter, and into an explanation for</a:t>
-            </a:r>
-          </a:p>
-          <a:p>
-            <a:r>
-              <a:t>the family. Three registers. Three vocabularies. Same facts.</a:t>
+              <a:t>The extraction table. A table with columns: finding, exact quoted wording, source location,</a:t>
+            </a:r>
+          </a:p>
+          <a:p>
+            <a:r>
+              <a:t>confidence — and the fallback. Use this whenever you're pulling facts out of a document. Notice</a:t>
+            </a:r>
+          </a:p>
+          <a:p>
+            <a:r>
+              <a:t>it combines everything from today: named columns, a quoted-wording column that makes claims</a:t>
+            </a:r>
+          </a:p>
+          <a:p>
+            <a:r>
+              <a:t>checkable, and a fallback so gaps don't get filled.</a:t>
             </a:r>
           </a:p>
           <a:p/>
           <a:p>
             <a:r>
-              <a:t>A contract review becomes a memo to the partner and an email to the client. An exam result</a:t>
-            </a:r>
-          </a:p>
-          <a:p>
-            <a:r>
-              <a:t>becomes a transcript entry, a report to parents, and feedback to the student.</a:t>
+              <a:t>The bounded summary. Three bullets, fifteen words maximum each, in order of importance. Then one</a:t>
+            </a:r>
+          </a:p>
+          <a:p>
+            <a:r>
+              <a:t>sentence naming anything important that had to be left out.</a:t>
             </a:r>
           </a:p>
           <a:p/>
           <a:p>
             <a:r>
-              <a:t>The bold line is the practical advice: do these as separate turns from the same source, not</a:t>
-            </a:r>
-          </a:p>
-          <a:p>
-            <a:r>
-              <a:t>as one request.</a:t>
+              <a:t>That last sentence is what makes the summary safe to skim, and I'd argue it's the single most</a:t>
+            </a:r>
+          </a:p>
+          <a:p>
+            <a:r>
+              <a:t>valuable line in this slide. A summary without it hides its own omissions — and omission, from</a:t>
+            </a:r>
+          </a:p>
+          <a:p>
+            <a:r>
+              <a:t>week one, is the failure you cannot detect by reading.</a:t>
             </a:r>
           </a:p>
           <a:p/>
           <a:p>
             <a:r>
-              <a:t>Why? Two reasons. If you ask for all three at once, they drift towards each other — the</a:t>
-            </a:r>
-          </a:p>
-          <a:p>
-            <a:r>
-              <a:t>model is producing one response, and there's a pull toward internal consistency of voice</a:t>
-            </a:r>
-          </a:p>
-          <a:p>
-            <a:r>
-              <a:t>across it. You get three versions that are more similar than they should be, which defeats</a:t>
-            </a:r>
-          </a:p>
-          <a:p>
-            <a:r>
-              <a:t>the point.</a:t>
+              <a:t>And the two-audience pair. Two versions under explicit headings, same facts, different register,</a:t>
+            </a:r>
+          </a:p>
+          <a:p>
+            <a:r>
+              <a:t>with a constraint that the second must not add anything the first didn't contain. That last</a:t>
+            </a:r>
+          </a:p>
+          <a:p>
+            <a:r>
+              <a:t>clause matters: without it, the family version tends to acquire reassurance that nobody</a:t>
+            </a:r>
+          </a:p>
+          <a:p>
+            <a:r>
+              <a:t>authorised.</a:t>
             </a:r>
           </a:p>
           <a:p/>
           <a:p>
             <a:r>
-              <a:t>And separate turns let you check each one before it goes anywhere. The family explanation</a:t>
-            </a:r>
-          </a:p>
-          <a:p>
-            <a:r>
-              <a:t>needs different scrutiny from the file note, and you want to give it that scrutiny</a:t>
-            </a:r>
-          </a:p>
-          <a:p>
-            <a:r>
-              <a:t>separately.</a:t>
-            </a:r>
-          </a:p>
-          <a:p/>
-          <a:p>
-            <a:r>
-              <a:t>This, incidentally, is one of the highest-value uses of these tools in professional practice.</a:t>
-            </a:r>
-          </a:p>
-          <a:p>
-            <a:r>
-              <a:t>Not writing things from nothing — re-pitching things you already have.</a:t>
+              <a:t>Write these down. They're reusable across every field in this room.</a:t>
             </a:r>
           </a:p>
         </p:txBody>
@@ -1471,7 +1468,81 @@
           <a:lstStyle/>
           <a:p>
             <a:r>
-              <a:t>Part four. Ten minutes. This one works fine with no device.</a:t>
+              <a:t>Here's a situation most of you will face, and it's under-discussed: writing in English for</a:t>
+            </a:r>
+          </a:p>
+          <a:p>
+            <a:r>
+              <a:t>readers whose first language is not English.</a:t>
+            </a:r>
+          </a:p>
+          <a:p/>
+          <a:p>
+            <a:r>
+              <a:t>The key insight is that this is a register problem, not a translation problem. The text stays in</a:t>
+            </a:r>
+          </a:p>
+          <a:p>
+            <a:r>
+              <a:t>English. What changes is field, and to some extent mode.</a:t>
+            </a:r>
+          </a:p>
+          <a:p/>
+          <a:p>
+            <a:r>
+              <a:t>Three moves. Ask for shorter sentences than you'd use for first-language readers. Ask it to</a:t>
+            </a:r>
+          </a:p>
+          <a:p>
+            <a:r>
+              <a:t>avoid idiom and phrasal verbs — "postpone" rather than "put off," "tolerate" rather than "put up</a:t>
+            </a:r>
+          </a:p>
+          <a:p>
+            <a:r>
+              <a:t>with." Phrasal verbs are one of the hardest parts of English for second-language readers and</a:t>
+            </a:r>
+          </a:p>
+          <a:p>
+            <a:r>
+              <a:t>they're everywhere in natural writing. And ask for the main point before the qualifications,</a:t>
+            </a:r>
+          </a:p>
+          <a:p>
+            <a:r>
+              <a:t>because a reader working harder to decode has less capacity left for holding a suspended clause.</a:t>
+            </a:r>
+          </a:p>
+          <a:p/>
+          <a:p>
+            <a:r>
+              <a:t>The instruction on the slide does all three at once: "the reader is a competent professional</a:t>
+            </a:r>
+          </a:p>
+          <a:p>
+            <a:r>
+              <a:t>reading in their second language. Avoid idiom. One idea per sentence."</a:t>
+            </a:r>
+          </a:p>
+          <a:p/>
+          <a:p>
+            <a:r>
+              <a:t>And read the last line carefully, because it's the part people get wrong. This is not</a:t>
+            </a:r>
+          </a:p>
+          <a:p>
+            <a:r>
+              <a:t>simplification, and it is not writing down to anyone. The reader is a competent professional —</a:t>
+            </a:r>
+          </a:p>
+          <a:p>
+            <a:r>
+              <a:t>you're removing incidental difficulty, not content. Getting that distinction wrong produces</a:t>
+            </a:r>
+          </a:p>
+          <a:p>
+            <a:r>
+              <a:t>patronising text, which is worse than difficult text.</a:t>
             </a:r>
           </a:p>
         </p:txBody>
@@ -1541,66 +1612,77 @@
           <a:lstStyle/>
           <a:p>
             <a:r>
-              <a:t>Ten minutes. The situation: a patient has missed two appointments and you need to contact</a:t>
-            </a:r>
-          </a:p>
-          <a:p>
-            <a:r>
-              <a:t>them. This is a real task, and getting it wrong in either direction has real consequences —</a:t>
-            </a:r>
-          </a:p>
-          <a:p>
-            <a:r>
-              <a:t>too soft and they miss a third, too hard and they disengage entirely.</a:t>
+              <a:t>A corrective, because today has been an argument for specificity and specificity has a limit.</a:t>
             </a:r>
           </a:p>
           <a:p/>
           <a:p>
             <a:r>
-              <a:t>Step one. Write the same message at three points on a ladder. Rung one: warm, no pressure.</a:t>
-            </a:r>
-          </a:p>
-          <a:p>
-            <a:r>
-              <a:t>Rung two: neutral and factual. Rung three: firm, with consequences stated.</a:t>
+              <a:t>Every constraint narrows the output. Enough of them and you narrow it to something useless.</a:t>
             </a:r>
           </a:p>
           <a:p/>
           <a:p>
             <a:r>
-              <a:t>Step two, and this is the actual learning. For each rung, write down the behaviours, not the</a:t>
-            </a:r>
-          </a:p>
-          <a:p>
-            <a:r>
-              <a:t>adjectives. What does the text do differently? Sentence length? How it opens? What</a:t>
-            </a:r>
-          </a:p>
-          <a:p>
-            <a:r>
-              <a:t>information comes first? Whether it asks or tells?</a:t>
+              <a:t>Three ways this bites. Fifteen simultaneous constraints tend to produce cautious, hedged,</a:t>
+            </a:r>
+          </a:p>
+          <a:p>
+            <a:r>
+              <a:t>lifeless text — the model is satisfying rules rather than doing the job, and you can feel it in</a:t>
+            </a:r>
+          </a:p>
+          <a:p>
+            <a:r>
+              <a:t>the result.</a:t>
             </a:r>
           </a:p>
           <a:p/>
           <a:p>
             <a:r>
-              <a:t>Step three. If you have a device, generate all three and compare them with yours — you'll</a:t>
-            </a:r>
-          </a:p>
-          <a:p>
-            <a:r>
-              <a:t>often find it makes a choice you didn't consider.</a:t>
+              <a:t>Conflicting constraints force an arbitrary choice you didn't make. "Be comprehensive" and "under</a:t>
+            </a:r>
+          </a:p>
+          <a:p>
+            <a:r>
+              <a:t>100 words" cannot both be honoured. Something gets dropped, and you don't get to choose what,</a:t>
+            </a:r>
+          </a:p>
+          <a:p>
+            <a:r>
+              <a:t>and you may not notice what went.</a:t>
             </a:r>
           </a:p>
           <a:p/>
           <a:p>
             <a:r>
-              <a:t>[If nobody has a device this still works completely; the comparison is on the next slide.</a:t>
-            </a:r>
-          </a:p>
-          <a:p>
-            <a:r>
-              <a:t>Two minutes of writing, then move on.]</a:t>
+              <a:t>And over-specifying format can suppress something you'd have wanted. If you demand exactly three</a:t>
+            </a:r>
+          </a:p>
+          <a:p>
+            <a:r>
+              <a:t>bullets and there were four important things, one is gone. The format won.</a:t>
+            </a:r>
+          </a:p>
+          <a:p/>
+          <a:p>
+            <a:r>
+              <a:t>The practical guide: three or four targeted constraints beat fifteen. And add them as problems</a:t>
+            </a:r>
+          </a:p>
+          <a:p>
+            <a:r>
+              <a:t>appear rather than in advance — which is the loop from last week. Diagnose, then constrain. Don't</a:t>
+            </a:r>
+          </a:p>
+          <a:p>
+            <a:r>
+              <a:t>pre-emptively defend against every failure you can imagine; you'll strangle the output before you</a:t>
+            </a:r>
+          </a:p>
+          <a:p>
+            <a:r>
+              <a:t>find out which failures actually happen.</a:t>
             </a:r>
           </a:p>
         </p:txBody>
@@ -1670,76 +1752,93 @@
           <a:lstStyle/>
           <a:p>
             <a:r>
-              <a:t>Here's what actually moves between the rungs, and none of it is the words people expect.</a:t>
+              <a:t>Here's a need that comes up constantly in professional work: the same content, correctly</a:t>
+            </a:r>
+          </a:p>
+          <a:p>
+            <a:r>
+              <a:t>pitched to different readers.</a:t>
             </a:r>
           </a:p>
           <a:p/>
           <a:p>
             <a:r>
-              <a:t>What comes first. The warm version opens with the person — "we hope you're well." The firm</a:t>
-            </a:r>
-          </a:p>
-          <a:p>
-            <a:r>
-              <a:t>version opens with the fact — "you have missed two appointments." Ordering carries more tone</a:t>
-            </a:r>
-          </a:p>
-          <a:p>
-            <a:r>
-              <a:t>than vocabulary does. You can write a firm message in gentle words if you lead with the</a:t>
-            </a:r>
-          </a:p>
-          <a:p>
-            <a:r>
-              <a:t>problem, and a soft message in blunt words if you lead with the person.</a:t>
+              <a:t>A clinical finding goes into the notes, into a referral letter, and into an explanation for</a:t>
+            </a:r>
+          </a:p>
+          <a:p>
+            <a:r>
+              <a:t>the family. Three registers. Three vocabularies. Same facts.</a:t>
             </a:r>
           </a:p>
           <a:p/>
           <a:p>
             <a:r>
-              <a:t>Who is the subject. "We would love to see you" versus "You have not attended." The warm</a:t>
-            </a:r>
-          </a:p>
-          <a:p>
-            <a:r>
-              <a:t>version makes the institution the actor; the firm version makes the reader the actor. This</a:t>
-            </a:r>
-          </a:p>
-          <a:p>
-            <a:r>
-              <a:t>single grammatical shift moves the tone further than any adjective you could add. Watch for</a:t>
-            </a:r>
-          </a:p>
-          <a:p>
-            <a:r>
-              <a:t>it in your own writing — it's how letters accidentally become accusatory.</a:t>
+              <a:t>A contract review becomes a memo to the partner and an email to the client. An exam result</a:t>
+            </a:r>
+          </a:p>
+          <a:p>
+            <a:r>
+              <a:t>becomes a transcript entry, a report to parents, and feedback to the student.</a:t>
             </a:r>
           </a:p>
           <a:p/>
           <a:p>
             <a:r>
-              <a:t>And what is left implicit. The warm version implies the consequence and trusts you to infer</a:t>
-            </a:r>
-          </a:p>
-          <a:p>
-            <a:r>
-              <a:t>it. The firm version states it. Neutral usually states it once, without elaboration.</a:t>
+              <a:t>The bold line is the practical advice: do these as separate turns from the same source, not</a:t>
+            </a:r>
+          </a:p>
+          <a:p>
+            <a:r>
+              <a:t>as one request.</a:t>
             </a:r>
           </a:p>
           <a:p/>
           <a:p>
             <a:r>
-              <a:t>That last one is the insight I'd want you to leave with: explicitness, not harshness, is</a:t>
-            </a:r>
-          </a:p>
-          <a:p>
-            <a:r>
-              <a:t>what people read as firm. If you want a message to land harder, you usually don't need</a:t>
-            </a:r>
-          </a:p>
-          <a:p>
-            <a:r>
-              <a:t>stronger words. You need to say the thing you were hinting at.</a:t>
+              <a:t>Why? Two reasons. If you ask for all three at once, they drift towards each other — the</a:t>
+            </a:r>
+          </a:p>
+          <a:p>
+            <a:r>
+              <a:t>model is producing one response, and there's a pull toward internal consistency of voice</a:t>
+            </a:r>
+          </a:p>
+          <a:p>
+            <a:r>
+              <a:t>across it. You get three versions that are more similar than they should be, which defeats</a:t>
+            </a:r>
+          </a:p>
+          <a:p>
+            <a:r>
+              <a:t>the point.</a:t>
+            </a:r>
+          </a:p>
+          <a:p/>
+          <a:p>
+            <a:r>
+              <a:t>And separate turns let you check each one before it goes anywhere. The family explanation</a:t>
+            </a:r>
+          </a:p>
+          <a:p>
+            <a:r>
+              <a:t>needs different scrutiny from the file note, and you want to give it that scrutiny</a:t>
+            </a:r>
+          </a:p>
+          <a:p>
+            <a:r>
+              <a:t>separately.</a:t>
+            </a:r>
+          </a:p>
+          <a:p/>
+          <a:p>
+            <a:r>
+              <a:t>This, incidentally, is one of the highest-value uses of these tools in professional practice.</a:t>
+            </a:r>
+          </a:p>
+          <a:p>
+            <a:r>
+              <a:t>Not writing things from nothing — re-pitching things you already have.</a:t>
             </a:r>
           </a:p>
         </p:txBody>
@@ -1809,95 +1908,7 @@
           <a:lstStyle/>
           <a:p>
             <a:r>
-              <a:t>Five things.</a:t>
-            </a:r>
-          </a:p>
-          <a:p/>
-          <a:p>
-            <a:r>
-              <a:t>"Professional" describes a feeling, not a text. Specify field, tenor and mode — subject</a:t>
-            </a:r>
-          </a:p>
-          <a:p>
-            <a:r>
-              <a:t>vocabulary, relationship, and channel.</a:t>
-            </a:r>
-          </a:p>
-          <a:p/>
-          <a:p>
-            <a:r>
-              <a:t>Translate tone adjectives into behaviours you can check. Warm means: use the name,</a:t>
-            </a:r>
-          </a:p>
-          <a:p>
-            <a:r>
-              <a:t>acknowledge the situation, thank them for something specific.</a:t>
-            </a:r>
-          </a:p>
-          <a:p/>
-          <a:p>
-            <a:r>
-              <a:t>Reading level is the highest-value style setting in clinical and legal communication, and</a:t>
-            </a:r>
-          </a:p>
-          <a:p>
-            <a:r>
-              <a:t>you can verify it by asking for a list of words the reader might not know.</a:t>
-            </a:r>
-          </a:p>
-          <a:p/>
-          <a:p>
-            <a:r>
-              <a:t>Always give a fallback. And remember why: you are not appealing to the model's honesty,</a:t>
-            </a:r>
-          </a:p>
-          <a:p>
-            <a:r>
-              <a:t>you're making the honest answer the probable one. That idea runs through the rest of the</a:t>
-            </a:r>
-          </a:p>
-          <a:p>
-            <a:r>
-              <a:t>course.</a:t>
-            </a:r>
-          </a:p>
-          <a:p/>
-          <a:p>
-            <a:r>
-              <a:t>Negative constraints work when they're specific and countable.</a:t>
-            </a:r>
-          </a:p>
-          <a:p/>
-          <a:p>
-            <a:r>
-              <a:t>Now — that's the foundation done. Five weeks of it. From next week the shape of the session</a:t>
-            </a:r>
-          </a:p>
-          <a:p>
-            <a:r>
-              <a:t>changes completely. I'll show you something working, we'll take it apart, and then you build</a:t>
-            </a:r>
-          </a:p>
-          <a:p>
-            <a:r>
-              <a:t>one. Next week you make a tool that runs in a browser, without writing code, and you'll be</a:t>
-            </a:r>
-          </a:p>
-          <a:p>
-            <a:r>
-              <a:t>able to send someone a link to it.</a:t>
-            </a:r>
-          </a:p>
-          <a:p/>
-          <a:p>
-            <a:r>
-              <a:t>Nothing to prepare. Bring a laptop if you have one.</a:t>
-            </a:r>
-          </a:p>
-          <a:p/>
-          <a:p>
-            <a:r>
-              <a:t>Questions?</a:t>
+              <a:t>Part four. Ten minutes. This one works fine with no device.</a:t>
             </a:r>
           </a:p>
         </p:txBody>
@@ -2055,6 +2066,432 @@
 </file>
 
 <file path=ppt/notesSlides/notesSlide20.xml><?xml version="1.0" encoding="utf-8"?>
+<p:notes xmlns:a="http://schemas.openxmlformats.org/drawingml/2006/main" xmlns:p="http://schemas.openxmlformats.org/presentationml/2006/main" xmlns:r="http://schemas.openxmlformats.org/officeDocument/2006/relationships">
+  <p:cSld>
+    <p:spTree>
+      <p:nvGrpSpPr>
+        <p:cNvPr id="1" name=""/>
+        <p:cNvGrpSpPr/>
+        <p:nvPr/>
+      </p:nvGrpSpPr>
+      <p:grpSpPr>
+        <a:xfrm>
+          <a:off x="0" y="0"/>
+          <a:ext cx="0" cy="0"/>
+          <a:chOff x="0" y="0"/>
+          <a:chExt cx="0" cy="0"/>
+        </a:xfrm>
+      </p:grpSpPr>
+      <p:sp>
+        <p:nvSpPr>
+          <p:cNvPr id="2" name="Slide Image Placeholder 1"/>
+          <p:cNvSpPr>
+            <a:spLocks noGrp="1"/>
+          </p:cNvSpPr>
+          <p:nvPr>
+            <p:ph type="sldImg" idx="2"/>
+          </p:nvPr>
+        </p:nvSpPr>
+        <p:spPr/>
+      </p:sp>
+      <p:sp>
+        <p:nvSpPr>
+          <p:cNvPr id="3" name="Notes Placeholder 2"/>
+          <p:cNvSpPr>
+            <a:spLocks noGrp="1"/>
+          </p:cNvSpPr>
+          <p:nvPr>
+            <p:ph type="body" idx="3" sz="quarter"/>
+          </p:nvPr>
+        </p:nvSpPr>
+        <p:spPr/>
+        <p:txBody>
+          <a:bodyPr/>
+          <a:lstStyle/>
+          <a:p>
+            <a:r>
+              <a:t>Ten minutes. The situation: a patient has missed two appointments and you need to contact</a:t>
+            </a:r>
+          </a:p>
+          <a:p>
+            <a:r>
+              <a:t>them. This is a real task, and getting it wrong in either direction has real consequences —</a:t>
+            </a:r>
+          </a:p>
+          <a:p>
+            <a:r>
+              <a:t>too soft and they miss a third, too hard and they disengage entirely.</a:t>
+            </a:r>
+          </a:p>
+          <a:p/>
+          <a:p>
+            <a:r>
+              <a:t>Step one. Write the same message at three points on a ladder. Rung one: warm, no pressure.</a:t>
+            </a:r>
+          </a:p>
+          <a:p>
+            <a:r>
+              <a:t>Rung two: neutral and factual. Rung three: firm, with consequences stated.</a:t>
+            </a:r>
+          </a:p>
+          <a:p/>
+          <a:p>
+            <a:r>
+              <a:t>Step two, and this is the actual learning. For each rung, write down the behaviours, not the</a:t>
+            </a:r>
+          </a:p>
+          <a:p>
+            <a:r>
+              <a:t>adjectives. What does the text do differently? Sentence length? How it opens? What</a:t>
+            </a:r>
+          </a:p>
+          <a:p>
+            <a:r>
+              <a:t>information comes first? Whether it asks or tells?</a:t>
+            </a:r>
+          </a:p>
+          <a:p/>
+          <a:p>
+            <a:r>
+              <a:t>Step three. If you have a device, generate all three and compare them with yours — you'll</a:t>
+            </a:r>
+          </a:p>
+          <a:p>
+            <a:r>
+              <a:t>often find it makes a choice you didn't consider.</a:t>
+            </a:r>
+          </a:p>
+          <a:p/>
+          <a:p>
+            <a:r>
+              <a:t>[If nobody has a device this still works completely; the comparison is on the next slide.</a:t>
+            </a:r>
+          </a:p>
+          <a:p>
+            <a:r>
+              <a:t>Two minutes of writing, then move on.]</a:t>
+            </a:r>
+          </a:p>
+        </p:txBody>
+      </p:sp>
+      <p:sp>
+        <p:nvSpPr>
+          <p:cNvPr id="4" name="Slide Number Placeholder 3"/>
+          <p:cNvSpPr>
+            <a:spLocks noGrp="1"/>
+          </p:cNvSpPr>
+          <p:nvPr>
+            <p:ph type="sldNum" idx="5" sz="quarter"/>
+          </p:nvPr>
+        </p:nvSpPr>
+        <p:spPr/>
+      </p:sp>
+    </p:spTree>
+  </p:cSld>
+  <p:clrMapOvr>
+    <a:masterClrMapping/>
+  </p:clrMapOvr>
+</p:notes>
+</file>
+
+<file path=ppt/notesSlides/notesSlide21.xml><?xml version="1.0" encoding="utf-8"?>
+<p:notes xmlns:a="http://schemas.openxmlformats.org/drawingml/2006/main" xmlns:p="http://schemas.openxmlformats.org/presentationml/2006/main" xmlns:r="http://schemas.openxmlformats.org/officeDocument/2006/relationships">
+  <p:cSld>
+    <p:spTree>
+      <p:nvGrpSpPr>
+        <p:cNvPr id="1" name=""/>
+        <p:cNvGrpSpPr/>
+        <p:nvPr/>
+      </p:nvGrpSpPr>
+      <p:grpSpPr>
+        <a:xfrm>
+          <a:off x="0" y="0"/>
+          <a:ext cx="0" cy="0"/>
+          <a:chOff x="0" y="0"/>
+          <a:chExt cx="0" cy="0"/>
+        </a:xfrm>
+      </p:grpSpPr>
+      <p:sp>
+        <p:nvSpPr>
+          <p:cNvPr id="2" name="Slide Image Placeholder 1"/>
+          <p:cNvSpPr>
+            <a:spLocks noGrp="1"/>
+          </p:cNvSpPr>
+          <p:nvPr>
+            <p:ph type="sldImg" idx="2"/>
+          </p:nvPr>
+        </p:nvSpPr>
+        <p:spPr/>
+      </p:sp>
+      <p:sp>
+        <p:nvSpPr>
+          <p:cNvPr id="3" name="Notes Placeholder 2"/>
+          <p:cNvSpPr>
+            <a:spLocks noGrp="1"/>
+          </p:cNvSpPr>
+          <p:nvPr>
+            <p:ph type="body" idx="3" sz="quarter"/>
+          </p:nvPr>
+        </p:nvSpPr>
+        <p:spPr/>
+        <p:txBody>
+          <a:bodyPr/>
+          <a:lstStyle/>
+          <a:p>
+            <a:r>
+              <a:t>Here's what actually moves between the rungs, and none of it is the words people expect.</a:t>
+            </a:r>
+          </a:p>
+          <a:p/>
+          <a:p>
+            <a:r>
+              <a:t>What comes first. The warm version opens with the person — "we hope you're well." The firm</a:t>
+            </a:r>
+          </a:p>
+          <a:p>
+            <a:r>
+              <a:t>version opens with the fact — "you have missed two appointments." Ordering carries more tone</a:t>
+            </a:r>
+          </a:p>
+          <a:p>
+            <a:r>
+              <a:t>than vocabulary does. You can write a firm message in gentle words if you lead with the</a:t>
+            </a:r>
+          </a:p>
+          <a:p>
+            <a:r>
+              <a:t>problem, and a soft message in blunt words if you lead with the person.</a:t>
+            </a:r>
+          </a:p>
+          <a:p/>
+          <a:p>
+            <a:r>
+              <a:t>Who is the subject. "We would love to see you" versus "You have not attended." The warm</a:t>
+            </a:r>
+          </a:p>
+          <a:p>
+            <a:r>
+              <a:t>version makes the institution the actor; the firm version makes the reader the actor. This</a:t>
+            </a:r>
+          </a:p>
+          <a:p>
+            <a:r>
+              <a:t>single grammatical shift moves the tone further than any adjective you could add. Watch for</a:t>
+            </a:r>
+          </a:p>
+          <a:p>
+            <a:r>
+              <a:t>it in your own writing — it's how letters accidentally become accusatory.</a:t>
+            </a:r>
+          </a:p>
+          <a:p/>
+          <a:p>
+            <a:r>
+              <a:t>And what is left implicit. The warm version implies the consequence and trusts you to infer</a:t>
+            </a:r>
+          </a:p>
+          <a:p>
+            <a:r>
+              <a:t>it. The firm version states it. Neutral usually states it once, without elaboration.</a:t>
+            </a:r>
+          </a:p>
+          <a:p/>
+          <a:p>
+            <a:r>
+              <a:t>That last one is the insight I'd want you to leave with: explicitness, not harshness, is</a:t>
+            </a:r>
+          </a:p>
+          <a:p>
+            <a:r>
+              <a:t>what people read as firm. If you want a message to land harder, you usually don't need</a:t>
+            </a:r>
+          </a:p>
+          <a:p>
+            <a:r>
+              <a:t>stronger words. You need to say the thing you were hinting at.</a:t>
+            </a:r>
+          </a:p>
+        </p:txBody>
+      </p:sp>
+      <p:sp>
+        <p:nvSpPr>
+          <p:cNvPr id="4" name="Slide Number Placeholder 3"/>
+          <p:cNvSpPr>
+            <a:spLocks noGrp="1"/>
+          </p:cNvSpPr>
+          <p:nvPr>
+            <p:ph type="sldNum" idx="5" sz="quarter"/>
+          </p:nvPr>
+        </p:nvSpPr>
+        <p:spPr/>
+      </p:sp>
+    </p:spTree>
+  </p:cSld>
+  <p:clrMapOvr>
+    <a:masterClrMapping/>
+  </p:clrMapOvr>
+</p:notes>
+</file>
+
+<file path=ppt/notesSlides/notesSlide22.xml><?xml version="1.0" encoding="utf-8"?>
+<p:notes xmlns:a="http://schemas.openxmlformats.org/drawingml/2006/main" xmlns:p="http://schemas.openxmlformats.org/presentationml/2006/main" xmlns:r="http://schemas.openxmlformats.org/officeDocument/2006/relationships">
+  <p:cSld>
+    <p:spTree>
+      <p:nvGrpSpPr>
+        <p:cNvPr id="1" name=""/>
+        <p:cNvGrpSpPr/>
+        <p:nvPr/>
+      </p:nvGrpSpPr>
+      <p:grpSpPr>
+        <a:xfrm>
+          <a:off x="0" y="0"/>
+          <a:ext cx="0" cy="0"/>
+          <a:chOff x="0" y="0"/>
+          <a:chExt cx="0" cy="0"/>
+        </a:xfrm>
+      </p:grpSpPr>
+      <p:sp>
+        <p:nvSpPr>
+          <p:cNvPr id="2" name="Slide Image Placeholder 1"/>
+          <p:cNvSpPr>
+            <a:spLocks noGrp="1"/>
+          </p:cNvSpPr>
+          <p:nvPr>
+            <p:ph type="sldImg" idx="2"/>
+          </p:nvPr>
+        </p:nvSpPr>
+        <p:spPr/>
+      </p:sp>
+      <p:sp>
+        <p:nvSpPr>
+          <p:cNvPr id="3" name="Notes Placeholder 2"/>
+          <p:cNvSpPr>
+            <a:spLocks noGrp="1"/>
+          </p:cNvSpPr>
+          <p:nvPr>
+            <p:ph type="body" idx="3" sz="quarter"/>
+          </p:nvPr>
+        </p:nvSpPr>
+        <p:spPr/>
+        <p:txBody>
+          <a:bodyPr/>
+          <a:lstStyle/>
+          <a:p>
+            <a:r>
+              <a:t>Five things.</a:t>
+            </a:r>
+          </a:p>
+          <a:p/>
+          <a:p>
+            <a:r>
+              <a:t>"Professional" describes a feeling, not a text. Specify field, tenor and mode — subject</a:t>
+            </a:r>
+          </a:p>
+          <a:p>
+            <a:r>
+              <a:t>vocabulary, relationship, and channel.</a:t>
+            </a:r>
+          </a:p>
+          <a:p/>
+          <a:p>
+            <a:r>
+              <a:t>Translate tone adjectives into behaviours you can check. Warm means: use the name,</a:t>
+            </a:r>
+          </a:p>
+          <a:p>
+            <a:r>
+              <a:t>acknowledge the situation, thank them for something specific.</a:t>
+            </a:r>
+          </a:p>
+          <a:p/>
+          <a:p>
+            <a:r>
+              <a:t>Reading level is the highest-value style setting in clinical and legal communication, and</a:t>
+            </a:r>
+          </a:p>
+          <a:p>
+            <a:r>
+              <a:t>you can verify it by asking for a list of words the reader might not know.</a:t>
+            </a:r>
+          </a:p>
+          <a:p/>
+          <a:p>
+            <a:r>
+              <a:t>Always give a fallback. And remember why: you are not appealing to the model's honesty,</a:t>
+            </a:r>
+          </a:p>
+          <a:p>
+            <a:r>
+              <a:t>you're making the honest answer the probable one. That idea runs through the rest of the</a:t>
+            </a:r>
+          </a:p>
+          <a:p>
+            <a:r>
+              <a:t>course.</a:t>
+            </a:r>
+          </a:p>
+          <a:p/>
+          <a:p>
+            <a:r>
+              <a:t>Negative constraints work when they're specific and countable.</a:t>
+            </a:r>
+          </a:p>
+          <a:p/>
+          <a:p>
+            <a:r>
+              <a:t>Now — that's the foundation done. Five weeks of it. From next week the shape of the session</a:t>
+            </a:r>
+          </a:p>
+          <a:p>
+            <a:r>
+              <a:t>changes completely. I'll show you something working, we'll take it apart, and then you build</a:t>
+            </a:r>
+          </a:p>
+          <a:p>
+            <a:r>
+              <a:t>one. Next week you make a tool that runs in a browser, without writing code, and you'll be</a:t>
+            </a:r>
+          </a:p>
+          <a:p>
+            <a:r>
+              <a:t>able to send someone a link to it.</a:t>
+            </a:r>
+          </a:p>
+          <a:p/>
+          <a:p>
+            <a:r>
+              <a:t>Nothing to prepare. Bring a laptop if you have one.</a:t>
+            </a:r>
+          </a:p>
+          <a:p/>
+          <a:p>
+            <a:r>
+              <a:t>Questions?</a:t>
+            </a:r>
+          </a:p>
+        </p:txBody>
+      </p:sp>
+      <p:sp>
+        <p:nvSpPr>
+          <p:cNvPr id="4" name="Slide Number Placeholder 3"/>
+          <p:cNvSpPr>
+            <a:spLocks noGrp="1"/>
+          </p:cNvSpPr>
+          <p:nvPr>
+            <p:ph type="sldNum" idx="5" sz="quarter"/>
+          </p:nvPr>
+        </p:nvSpPr>
+        <p:spPr/>
+      </p:sp>
+    </p:spTree>
+  </p:cSld>
+  <p:clrMapOvr>
+    <a:masterClrMapping/>
+  </p:clrMapOvr>
+</p:notes>
+</file>
+
+<file path=ppt/notesSlides/notesSlide23.xml><?xml version="1.0" encoding="utf-8"?>
 <p:notes xmlns:a="http://schemas.openxmlformats.org/drawingml/2006/main" xmlns:p="http://schemas.openxmlformats.org/presentationml/2006/main" xmlns:r="http://schemas.openxmlformats.org/officeDocument/2006/relationships">
   <p:cSld>
     <p:spTree>
@@ -8359,7 +8796,7 @@
                 </a:solidFill>
                 <a:latin typeface="Calibri Light"/>
               </a:rPr>
-              <a:t>One Source, Several Audiences</a:t>
+              <a:t>Three Format Specifications Worth Reusing</a:t>
             </a:r>
           </a:p>
         </p:txBody>
@@ -8410,14 +8847,542 @@
       </p:sp>
       <p:sp>
         <p:nvSpPr>
-          <p:cNvPr id="4" name="TextBox 3"/>
+          <p:cNvPr id="4" name="Rounded Rectangle 3"/>
+          <p:cNvSpPr/>
+          <p:nvPr/>
+        </p:nvSpPr>
+        <p:spPr>
+          <a:xfrm>
+            <a:off x="777240" y="2057400"/>
+            <a:ext cx="3301898" cy="3200400"/>
+          </a:xfrm>
+          <a:prstGeom prst="roundRect">
+            <a:avLst>
+              <a:gd name="adj" fmla="val 10000"/>
+            </a:avLst>
+          </a:prstGeom>
+          <a:solidFill>
+            <a:srgbClr val="F1F5F9"/>
+          </a:solidFill>
+          <a:ln w="15875">
+            <a:solidFill>
+              <a:srgbClr val="D3DDE6"/>
+            </a:solidFill>
+          </a:ln>
+          <a:effectLst/>
+        </p:spPr>
+        <p:style>
+          <a:lnRef idx="1">
+            <a:schemeClr val="accent1"/>
+          </a:lnRef>
+          <a:fillRef idx="3">
+            <a:schemeClr val="accent1"/>
+          </a:fillRef>
+          <a:effectRef idx="2">
+            <a:schemeClr val="accent1"/>
+          </a:effectRef>
+          <a:fontRef idx="minor">
+            <a:schemeClr val="lt1"/>
+          </a:fontRef>
+        </p:style>
+        <p:txBody>
+          <a:bodyPr rtlCol="0" anchor="ctr"/>
+          <a:lstStyle/>
+          <a:p>
+            <a:pPr algn="ctr"/>
+          </a:p>
+        </p:txBody>
+      </p:sp>
+      <p:sp>
+        <p:nvSpPr>
+          <p:cNvPr id="5" name="Rectangle 4"/>
+          <p:cNvSpPr/>
+          <p:nvPr/>
+        </p:nvSpPr>
+        <p:spPr>
+          <a:xfrm>
+            <a:off x="978408" y="2331720"/>
+            <a:ext cx="640080" cy="38100"/>
+          </a:xfrm>
+          <a:prstGeom prst="rect">
+            <a:avLst/>
+          </a:prstGeom>
+          <a:solidFill>
+            <a:srgbClr val="0F766E"/>
+          </a:solidFill>
+          <a:ln>
+            <a:noFill/>
+          </a:ln>
+          <a:effectLst/>
+        </p:spPr>
+        <p:style>
+          <a:lnRef idx="1">
+            <a:schemeClr val="accent1"/>
+          </a:lnRef>
+          <a:fillRef idx="3">
+            <a:schemeClr val="accent1"/>
+          </a:fillRef>
+          <a:effectRef idx="2">
+            <a:schemeClr val="accent1"/>
+          </a:effectRef>
+          <a:fontRef idx="minor">
+            <a:schemeClr val="lt1"/>
+          </a:fontRef>
+        </p:style>
+        <p:txBody>
+          <a:bodyPr rtlCol="0" anchor="ctr"/>
+          <a:lstStyle/>
+          <a:p>
+            <a:pPr algn="ctr"/>
+          </a:p>
+        </p:txBody>
+      </p:sp>
+      <p:sp>
+        <p:nvSpPr>
+          <p:cNvPr id="6" name="TextBox 5"/>
           <p:cNvSpPr txBox="1"/>
           <p:nvPr/>
         </p:nvSpPr>
         <p:spPr>
           <a:xfrm>
-            <a:off x="777240" y="1783080"/>
-            <a:ext cx="10637215" cy="4343400"/>
+            <a:off x="978408" y="2560320"/>
+            <a:ext cx="2899562" cy="640080"/>
+          </a:xfrm>
+          <a:prstGeom prst="rect">
+            <a:avLst/>
+          </a:prstGeom>
+          <a:noFill/>
+        </p:spPr>
+        <p:txBody>
+          <a:bodyPr wrap="square" lIns="0" rIns="0" tIns="0" bIns="0" anchor="t">
+            <a:spAutoFit/>
+          </a:bodyPr>
+          <a:lstStyle/>
+          <a:p>
+            <a:pPr algn="l">
+              <a:lnSpc>
+                <a:spcPct val="105000"/>
+              </a:lnSpc>
+              <a:spcAft>
+                <a:spcPts val="200"/>
+              </a:spcAft>
+            </a:pPr>
+            <a:r>
+              <a:rPr sz="1800" b="1" i="0">
+                <a:solidFill>
+                  <a:srgbClr val="1F2937"/>
+                </a:solidFill>
+                <a:latin typeface="Calibri"/>
+              </a:rPr>
+              <a:t>The extraction table</a:t>
+            </a:r>
+          </a:p>
+        </p:txBody>
+      </p:sp>
+      <p:sp>
+        <p:nvSpPr>
+          <p:cNvPr id="7" name="TextBox 6"/>
+          <p:cNvSpPr txBox="1"/>
+          <p:nvPr/>
+        </p:nvSpPr>
+        <p:spPr>
+          <a:xfrm>
+            <a:off x="978408" y="3246120"/>
+            <a:ext cx="2899562" cy="1737360"/>
+          </a:xfrm>
+          <a:prstGeom prst="rect">
+            <a:avLst/>
+          </a:prstGeom>
+          <a:noFill/>
+        </p:spPr>
+        <p:txBody>
+          <a:bodyPr wrap="square" lIns="0" rIns="0" tIns="0" bIns="0" anchor="t">
+            <a:spAutoFit/>
+          </a:bodyPr>
+          <a:lstStyle/>
+          <a:p>
+            <a:pPr algn="l">
+              <a:lnSpc>
+                <a:spcPct val="105000"/>
+              </a:lnSpc>
+              <a:spcAft>
+                <a:spcPts val="200"/>
+              </a:spcAft>
+            </a:pPr>
+            <a:r>
+              <a:rPr sz="1350" b="0" i="0">
+                <a:solidFill>
+                  <a:srgbClr val="333D4B"/>
+                </a:solidFill>
+                <a:latin typeface="Calibri"/>
+              </a:rPr>
+              <a:t>"A table with columns: finding, exact quoted wording, source location, confidence. If a field cannot be filled from the source, write NOT STATED." Use whenever you are pulling facts out of a document.</a:t>
+            </a:r>
+          </a:p>
+        </p:txBody>
+      </p:sp>
+      <p:sp>
+        <p:nvSpPr>
+          <p:cNvPr id="8" name="Rounded Rectangle 7"/>
+          <p:cNvSpPr/>
+          <p:nvPr/>
+        </p:nvSpPr>
+        <p:spPr>
+          <a:xfrm>
+            <a:off x="4444898" y="2057400"/>
+            <a:ext cx="3301898" cy="3200400"/>
+          </a:xfrm>
+          <a:prstGeom prst="roundRect">
+            <a:avLst>
+              <a:gd name="adj" fmla="val 10000"/>
+            </a:avLst>
+          </a:prstGeom>
+          <a:solidFill>
+            <a:srgbClr val="F1F5F9"/>
+          </a:solidFill>
+          <a:ln w="15875">
+            <a:solidFill>
+              <a:srgbClr val="D3DDE6"/>
+            </a:solidFill>
+          </a:ln>
+          <a:effectLst/>
+        </p:spPr>
+        <p:style>
+          <a:lnRef idx="1">
+            <a:schemeClr val="accent1"/>
+          </a:lnRef>
+          <a:fillRef idx="3">
+            <a:schemeClr val="accent1"/>
+          </a:fillRef>
+          <a:effectRef idx="2">
+            <a:schemeClr val="accent1"/>
+          </a:effectRef>
+          <a:fontRef idx="minor">
+            <a:schemeClr val="lt1"/>
+          </a:fontRef>
+        </p:style>
+        <p:txBody>
+          <a:bodyPr rtlCol="0" anchor="ctr"/>
+          <a:lstStyle/>
+          <a:p>
+            <a:pPr algn="ctr"/>
+          </a:p>
+        </p:txBody>
+      </p:sp>
+      <p:sp>
+        <p:nvSpPr>
+          <p:cNvPr id="9" name="Rectangle 8"/>
+          <p:cNvSpPr/>
+          <p:nvPr/>
+        </p:nvSpPr>
+        <p:spPr>
+          <a:xfrm>
+            <a:off x="4646066" y="2331720"/>
+            <a:ext cx="640080" cy="38100"/>
+          </a:xfrm>
+          <a:prstGeom prst="rect">
+            <a:avLst/>
+          </a:prstGeom>
+          <a:solidFill>
+            <a:srgbClr val="0F766E"/>
+          </a:solidFill>
+          <a:ln>
+            <a:noFill/>
+          </a:ln>
+          <a:effectLst/>
+        </p:spPr>
+        <p:style>
+          <a:lnRef idx="1">
+            <a:schemeClr val="accent1"/>
+          </a:lnRef>
+          <a:fillRef idx="3">
+            <a:schemeClr val="accent1"/>
+          </a:fillRef>
+          <a:effectRef idx="2">
+            <a:schemeClr val="accent1"/>
+          </a:effectRef>
+          <a:fontRef idx="minor">
+            <a:schemeClr val="lt1"/>
+          </a:fontRef>
+        </p:style>
+        <p:txBody>
+          <a:bodyPr rtlCol="0" anchor="ctr"/>
+          <a:lstStyle/>
+          <a:p>
+            <a:pPr algn="ctr"/>
+          </a:p>
+        </p:txBody>
+      </p:sp>
+      <p:sp>
+        <p:nvSpPr>
+          <p:cNvPr id="10" name="TextBox 9"/>
+          <p:cNvSpPr txBox="1"/>
+          <p:nvPr/>
+        </p:nvSpPr>
+        <p:spPr>
+          <a:xfrm>
+            <a:off x="4646066" y="2560320"/>
+            <a:ext cx="2899562" cy="640080"/>
+          </a:xfrm>
+          <a:prstGeom prst="rect">
+            <a:avLst/>
+          </a:prstGeom>
+          <a:noFill/>
+        </p:spPr>
+        <p:txBody>
+          <a:bodyPr wrap="square" lIns="0" rIns="0" tIns="0" bIns="0" anchor="t">
+            <a:spAutoFit/>
+          </a:bodyPr>
+          <a:lstStyle/>
+          <a:p>
+            <a:pPr algn="l">
+              <a:lnSpc>
+                <a:spcPct val="105000"/>
+              </a:lnSpc>
+              <a:spcAft>
+                <a:spcPts val="200"/>
+              </a:spcAft>
+            </a:pPr>
+            <a:r>
+              <a:rPr sz="1800" b="1" i="0">
+                <a:solidFill>
+                  <a:srgbClr val="1F2937"/>
+                </a:solidFill>
+                <a:latin typeface="Calibri"/>
+              </a:rPr>
+              <a:t>The bounded summary</a:t>
+            </a:r>
+          </a:p>
+        </p:txBody>
+      </p:sp>
+      <p:sp>
+        <p:nvSpPr>
+          <p:cNvPr id="11" name="TextBox 10"/>
+          <p:cNvSpPr txBox="1"/>
+          <p:nvPr/>
+        </p:nvSpPr>
+        <p:spPr>
+          <a:xfrm>
+            <a:off x="4646066" y="3246120"/>
+            <a:ext cx="2899562" cy="1737360"/>
+          </a:xfrm>
+          <a:prstGeom prst="rect">
+            <a:avLst/>
+          </a:prstGeom>
+          <a:noFill/>
+        </p:spPr>
+        <p:txBody>
+          <a:bodyPr wrap="square" lIns="0" rIns="0" tIns="0" bIns="0" anchor="t">
+            <a:spAutoFit/>
+          </a:bodyPr>
+          <a:lstStyle/>
+          <a:p>
+            <a:pPr algn="l">
+              <a:lnSpc>
+                <a:spcPct val="105000"/>
+              </a:lnSpc>
+              <a:spcAft>
+                <a:spcPts val="200"/>
+              </a:spcAft>
+            </a:pPr>
+            <a:r>
+              <a:rPr sz="1350" b="0" i="0">
+                <a:solidFill>
+                  <a:srgbClr val="333D4B"/>
+                </a:solidFill>
+                <a:latin typeface="Calibri"/>
+              </a:rPr>
+              <a:t>"Three bullets, maximum fifteen words each, in order of importance. Then one sentence naming anything important you had to leave out." That final sentence is what makes it safe to skim.</a:t>
+            </a:r>
+          </a:p>
+        </p:txBody>
+      </p:sp>
+      <p:sp>
+        <p:nvSpPr>
+          <p:cNvPr id="12" name="Rounded Rectangle 11"/>
+          <p:cNvSpPr/>
+          <p:nvPr/>
+        </p:nvSpPr>
+        <p:spPr>
+          <a:xfrm>
+            <a:off x="8112556" y="2057400"/>
+            <a:ext cx="3301898" cy="3200400"/>
+          </a:xfrm>
+          <a:prstGeom prst="roundRect">
+            <a:avLst>
+              <a:gd name="adj" fmla="val 10000"/>
+            </a:avLst>
+          </a:prstGeom>
+          <a:solidFill>
+            <a:srgbClr val="F1F5F9"/>
+          </a:solidFill>
+          <a:ln w="15875">
+            <a:solidFill>
+              <a:srgbClr val="D3DDE6"/>
+            </a:solidFill>
+          </a:ln>
+          <a:effectLst/>
+        </p:spPr>
+        <p:style>
+          <a:lnRef idx="1">
+            <a:schemeClr val="accent1"/>
+          </a:lnRef>
+          <a:fillRef idx="3">
+            <a:schemeClr val="accent1"/>
+          </a:fillRef>
+          <a:effectRef idx="2">
+            <a:schemeClr val="accent1"/>
+          </a:effectRef>
+          <a:fontRef idx="minor">
+            <a:schemeClr val="lt1"/>
+          </a:fontRef>
+        </p:style>
+        <p:txBody>
+          <a:bodyPr rtlCol="0" anchor="ctr"/>
+          <a:lstStyle/>
+          <a:p>
+            <a:pPr algn="ctr"/>
+          </a:p>
+        </p:txBody>
+      </p:sp>
+      <p:sp>
+        <p:nvSpPr>
+          <p:cNvPr id="13" name="Rectangle 12"/>
+          <p:cNvSpPr/>
+          <p:nvPr/>
+        </p:nvSpPr>
+        <p:spPr>
+          <a:xfrm>
+            <a:off x="8313724" y="2331720"/>
+            <a:ext cx="640080" cy="38100"/>
+          </a:xfrm>
+          <a:prstGeom prst="rect">
+            <a:avLst/>
+          </a:prstGeom>
+          <a:solidFill>
+            <a:srgbClr val="0F766E"/>
+          </a:solidFill>
+          <a:ln>
+            <a:noFill/>
+          </a:ln>
+          <a:effectLst/>
+        </p:spPr>
+        <p:style>
+          <a:lnRef idx="1">
+            <a:schemeClr val="accent1"/>
+          </a:lnRef>
+          <a:fillRef idx="3">
+            <a:schemeClr val="accent1"/>
+          </a:fillRef>
+          <a:effectRef idx="2">
+            <a:schemeClr val="accent1"/>
+          </a:effectRef>
+          <a:fontRef idx="minor">
+            <a:schemeClr val="lt1"/>
+          </a:fontRef>
+        </p:style>
+        <p:txBody>
+          <a:bodyPr rtlCol="0" anchor="ctr"/>
+          <a:lstStyle/>
+          <a:p>
+            <a:pPr algn="ctr"/>
+          </a:p>
+        </p:txBody>
+      </p:sp>
+      <p:sp>
+        <p:nvSpPr>
+          <p:cNvPr id="14" name="TextBox 13"/>
+          <p:cNvSpPr txBox="1"/>
+          <p:nvPr/>
+        </p:nvSpPr>
+        <p:spPr>
+          <a:xfrm>
+            <a:off x="8313724" y="2560320"/>
+            <a:ext cx="2899562" cy="640080"/>
+          </a:xfrm>
+          <a:prstGeom prst="rect">
+            <a:avLst/>
+          </a:prstGeom>
+          <a:noFill/>
+        </p:spPr>
+        <p:txBody>
+          <a:bodyPr wrap="square" lIns="0" rIns="0" tIns="0" bIns="0" anchor="t">
+            <a:spAutoFit/>
+          </a:bodyPr>
+          <a:lstStyle/>
+          <a:p>
+            <a:pPr algn="l">
+              <a:lnSpc>
+                <a:spcPct val="105000"/>
+              </a:lnSpc>
+              <a:spcAft>
+                <a:spcPts val="200"/>
+              </a:spcAft>
+            </a:pPr>
+            <a:r>
+              <a:rPr sz="1800" b="1" i="0">
+                <a:solidFill>
+                  <a:srgbClr val="1F2937"/>
+                </a:solidFill>
+                <a:latin typeface="Calibri"/>
+              </a:rPr>
+              <a:t>The two-audience pair</a:t>
+            </a:r>
+          </a:p>
+        </p:txBody>
+      </p:sp>
+      <p:sp>
+        <p:nvSpPr>
+          <p:cNvPr id="15" name="TextBox 14"/>
+          <p:cNvSpPr txBox="1"/>
+          <p:nvPr/>
+        </p:nvSpPr>
+        <p:spPr>
+          <a:xfrm>
+            <a:off x="8313724" y="3246120"/>
+            <a:ext cx="2899562" cy="1737360"/>
+          </a:xfrm>
+          <a:prstGeom prst="rect">
+            <a:avLst/>
+          </a:prstGeom>
+          <a:noFill/>
+        </p:spPr>
+        <p:txBody>
+          <a:bodyPr wrap="square" lIns="0" rIns="0" tIns="0" bIns="0" anchor="t">
+            <a:spAutoFit/>
+          </a:bodyPr>
+          <a:lstStyle/>
+          <a:p>
+            <a:pPr algn="l">
+              <a:lnSpc>
+                <a:spcPct val="105000"/>
+              </a:lnSpc>
+              <a:spcAft>
+                <a:spcPts val="200"/>
+              </a:spcAft>
+            </a:pPr>
+            <a:r>
+              <a:rPr sz="1350" b="0" i="0">
+                <a:solidFill>
+                  <a:srgbClr val="333D4B"/>
+                </a:solidFill>
+                <a:latin typeface="Calibri"/>
+              </a:rPr>
+              <a:t>"Produce two versions under headings FOR THE FILE and FOR THE FAMILY. Same facts, different register. Do not add anything to the second that is not in the first."</a:t>
+            </a:r>
+          </a:p>
+        </p:txBody>
+      </p:sp>
+      <p:sp>
+        <p:nvSpPr>
+          <p:cNvPr id="16" name="TextBox 15"/>
+          <p:cNvSpPr txBox="1"/>
+          <p:nvPr/>
+        </p:nvSpPr>
+        <p:spPr>
+          <a:xfrm>
+            <a:off x="777240" y="6355080"/>
+            <a:ext cx="10637215" cy="274320"/>
           </a:xfrm>
           <a:prstGeom prst="rect">
             <a:avLst/>
@@ -8430,182 +9395,6 @@
           </a:bodyPr>
           <a:lstStyle/>
           <a:p>
-            <a:pPr>
-              <a:lnSpc>
-                <a:spcPct val="115000"/>
-              </a:lnSpc>
-              <a:spcAft>
-                <a:spcPts val="1000"/>
-              </a:spcAft>
-            </a:pPr>
-            <a:r>
-              <a:rPr sz="1900" b="0" i="0">
-                <a:solidFill>
-                  <a:srgbClr val="1F2937"/>
-                </a:solidFill>
-                <a:latin typeface="Calibri"/>
-              </a:rPr>
-              <a:t>•  A common professional need: the same content, correctly pitched to different readers</a:t>
-            </a:r>
-          </a:p>
-          <a:p>
-            <a:pPr>
-              <a:lnSpc>
-                <a:spcPct val="115000"/>
-              </a:lnSpc>
-              <a:spcAft>
-                <a:spcPts val="1000"/>
-              </a:spcAft>
-            </a:pPr>
-          </a:p>
-          <a:p>
-            <a:pPr lvl="1">
-              <a:lnSpc>
-                <a:spcPct val="115000"/>
-              </a:lnSpc>
-              <a:spcAft>
-                <a:spcPts val="500"/>
-              </a:spcAft>
-            </a:pPr>
-            <a:r>
-              <a:rPr sz="1600" b="0" i="0">
-                <a:solidFill>
-                  <a:srgbClr val="333D4B"/>
-                </a:solidFill>
-                <a:latin typeface="Calibri"/>
-              </a:rPr>
-              <a:t>—  A clinical finding → the notes, the referral letter, and the explanation to the family</a:t>
-            </a:r>
-          </a:p>
-          <a:p>
-            <a:pPr lvl="1">
-              <a:lnSpc>
-                <a:spcPct val="115000"/>
-              </a:lnSpc>
-              <a:spcAft>
-                <a:spcPts val="500"/>
-              </a:spcAft>
-            </a:pPr>
-            <a:r>
-              <a:rPr sz="1600" b="0" i="0">
-                <a:solidFill>
-                  <a:srgbClr val="333D4B"/>
-                </a:solidFill>
-                <a:latin typeface="Calibri"/>
-              </a:rPr>
-              <a:t>—  A contract review → the memo to the partner and the email to the client</a:t>
-            </a:r>
-          </a:p>
-          <a:p>
-            <a:pPr lvl="1">
-              <a:lnSpc>
-                <a:spcPct val="115000"/>
-              </a:lnSpc>
-              <a:spcAft>
-                <a:spcPts val="500"/>
-              </a:spcAft>
-            </a:pPr>
-            <a:r>
-              <a:rPr sz="1600" b="0" i="0">
-                <a:solidFill>
-                  <a:srgbClr val="333D4B"/>
-                </a:solidFill>
-                <a:latin typeface="Calibri"/>
-              </a:rPr>
-              <a:t>—  An exam result → the transcript, the report to parents, the feedback to the student</a:t>
-            </a:r>
-          </a:p>
-          <a:p>
-            <a:pPr>
-              <a:lnSpc>
-                <a:spcPct val="115000"/>
-              </a:lnSpc>
-              <a:spcAft>
-                <a:spcPts val="1000"/>
-              </a:spcAft>
-            </a:pPr>
-          </a:p>
-          <a:p>
-            <a:pPr>
-              <a:lnSpc>
-                <a:spcPct val="115000"/>
-              </a:lnSpc>
-              <a:spcAft>
-                <a:spcPts val="1000"/>
-              </a:spcAft>
-            </a:pPr>
-            <a:r>
-              <a:rPr sz="1900" b="1" i="0">
-                <a:solidFill>
-                  <a:srgbClr val="1F2937"/>
-                </a:solidFill>
-                <a:latin typeface="Calibri"/>
-              </a:rPr>
-              <a:t>•  Do them as separate turns from the same source, not as one request.</a:t>
-            </a:r>
-          </a:p>
-          <a:p>
-            <a:pPr lvl="1">
-              <a:lnSpc>
-                <a:spcPct val="115000"/>
-              </a:lnSpc>
-              <a:spcAft>
-                <a:spcPts val="500"/>
-              </a:spcAft>
-            </a:pPr>
-            <a:r>
-              <a:rPr sz="1600" b="0" i="0">
-                <a:solidFill>
-                  <a:srgbClr val="333D4B"/>
-                </a:solidFill>
-                <a:latin typeface="Calibri"/>
-              </a:rPr>
-              <a:t>—  One request produces three versions that drift towards each other</a:t>
-            </a:r>
-          </a:p>
-          <a:p>
-            <a:pPr lvl="1">
-              <a:lnSpc>
-                <a:spcPct val="115000"/>
-              </a:lnSpc>
-              <a:spcAft>
-                <a:spcPts val="500"/>
-              </a:spcAft>
-            </a:pPr>
-            <a:r>
-              <a:rPr sz="1600" b="0" i="0">
-                <a:solidFill>
-                  <a:srgbClr val="333D4B"/>
-                </a:solidFill>
-                <a:latin typeface="Calibri"/>
-              </a:rPr>
-              <a:t>—  Separate turns keep each register clean — and let you check each before sending</a:t>
-            </a:r>
-          </a:p>
-        </p:txBody>
-      </p:sp>
-      <p:sp>
-        <p:nvSpPr>
-          <p:cNvPr id="5" name="TextBox 4"/>
-          <p:cNvSpPr txBox="1"/>
-          <p:nvPr/>
-        </p:nvSpPr>
-        <p:spPr>
-          <a:xfrm>
-            <a:off x="777240" y="6355080"/>
-            <a:ext cx="10637215" cy="274320"/>
-          </a:xfrm>
-          <a:prstGeom prst="rect">
-            <a:avLst/>
-          </a:prstGeom>
-          <a:noFill/>
-        </p:spPr>
-        <p:txBody>
-          <a:bodyPr wrap="square" lIns="0" rIns="0" tIns="0" bIns="0">
-            <a:spAutoFit/>
-          </a:bodyPr>
-          <a:lstStyle/>
-          <a:p>
             <a:r>
               <a:rPr sz="1000" b="0" i="0">
                 <a:solidFill>
@@ -8620,7 +9409,7 @@
       </p:sp>
       <p:sp>
         <p:nvSpPr>
-          <p:cNvPr id="6" name="TextBox 5"/>
+          <p:cNvPr id="17" name="TextBox 16"/>
           <p:cNvSpPr txBox="1"/>
           <p:nvPr/>
         </p:nvSpPr>
@@ -8673,14 +9462,48 @@
       <p:grpSpPr/>
       <p:sp>
         <p:nvSpPr>
-          <p:cNvPr id="2" name="Rectangle 1"/>
+          <p:cNvPr id="2" name="TextBox 1"/>
+          <p:cNvSpPr txBox="1"/>
+          <p:nvPr/>
+        </p:nvSpPr>
+        <p:spPr>
+          <a:xfrm>
+            <a:off x="777240" y="566928"/>
+            <a:ext cx="10637215" cy="822960"/>
+          </a:xfrm>
+          <a:prstGeom prst="rect">
+            <a:avLst/>
+          </a:prstGeom>
+          <a:noFill/>
+        </p:spPr>
+        <p:txBody>
+          <a:bodyPr wrap="square" lIns="0" rIns="0" tIns="0" bIns="0">
+            <a:spAutoFit/>
+          </a:bodyPr>
+          <a:lstStyle/>
+          <a:p>
+            <a:r>
+              <a:rPr sz="3000" b="1" i="0">
+                <a:solidFill>
+                  <a:srgbClr val="1F2937"/>
+                </a:solidFill>
+                <a:latin typeface="Calibri Light"/>
+              </a:rPr>
+              <a:t>Writing in English for Turkish Readers</a:t>
+            </a:r>
+          </a:p>
+        </p:txBody>
+      </p:sp>
+      <p:sp>
+        <p:nvSpPr>
+          <p:cNvPr id="3" name="Rectangle 2"/>
           <p:cNvSpPr/>
           <p:nvPr/>
         </p:nvSpPr>
         <p:spPr>
           <a:xfrm>
-            <a:off x="0" y="0"/>
-            <a:ext cx="292608" cy="6858000"/>
+            <a:off x="777240" y="1417320"/>
+            <a:ext cx="1051560" cy="38100"/>
           </a:xfrm>
           <a:prstGeom prst="rect">
             <a:avLst/>
@@ -8717,14 +9540,14 @@
       </p:sp>
       <p:sp>
         <p:nvSpPr>
-          <p:cNvPr id="3" name="TextBox 2"/>
+          <p:cNvPr id="4" name="TextBox 3"/>
           <p:cNvSpPr txBox="1"/>
           <p:nvPr/>
         </p:nvSpPr>
         <p:spPr>
           <a:xfrm>
-            <a:off x="1280160" y="2743200"/>
-            <a:ext cx="10058400" cy="457200"/>
+            <a:off x="777240" y="1783080"/>
+            <a:ext cx="10637215" cy="4343400"/>
           </a:xfrm>
           <a:prstGeom prst="rect">
             <a:avLst/>
@@ -8737,28 +9560,170 @@
           </a:bodyPr>
           <a:lstStyle/>
           <a:p>
-            <a:r>
-              <a:rPr sz="1400" b="1" i="0">
-                <a:solidFill>
-                  <a:srgbClr val="0F766E"/>
-                </a:solidFill>
-                <a:latin typeface="Calibri"/>
-              </a:rPr>
-              <a:t>PART 4</a:t>
-            </a:r>
-          </a:p>
-        </p:txBody>
-      </p:sp>
-      <p:sp>
-        <p:nvSpPr>
-          <p:cNvPr id="4" name="TextBox 3"/>
+            <a:pPr>
+              <a:lnSpc>
+                <a:spcPct val="115000"/>
+              </a:lnSpc>
+              <a:spcAft>
+                <a:spcPts val="1000"/>
+              </a:spcAft>
+            </a:pPr>
+            <a:r>
+              <a:rPr sz="1900" b="0" i="0">
+                <a:solidFill>
+                  <a:srgbClr val="1F2937"/>
+                </a:solidFill>
+                <a:latin typeface="Calibri"/>
+              </a:rPr>
+              <a:t>•  A situation most of you will face, and it is a register problem rather than a translation problem</a:t>
+            </a:r>
+          </a:p>
+          <a:p>
+            <a:pPr>
+              <a:lnSpc>
+                <a:spcPct val="115000"/>
+              </a:lnSpc>
+              <a:spcAft>
+                <a:spcPts val="1000"/>
+              </a:spcAft>
+            </a:pPr>
+          </a:p>
+          <a:p>
+            <a:pPr lvl="1">
+              <a:lnSpc>
+                <a:spcPct val="115000"/>
+              </a:lnSpc>
+              <a:spcAft>
+                <a:spcPts val="500"/>
+              </a:spcAft>
+            </a:pPr>
+            <a:r>
+              <a:rPr sz="1600" b="0" i="0">
+                <a:solidFill>
+                  <a:srgbClr val="333D4B"/>
+                </a:solidFill>
+                <a:latin typeface="Calibri"/>
+              </a:rPr>
+              <a:t>—  Ask for shorter sentences than you would use for first-language readers</a:t>
+            </a:r>
+          </a:p>
+          <a:p>
+            <a:pPr lvl="1">
+              <a:lnSpc>
+                <a:spcPct val="115000"/>
+              </a:lnSpc>
+              <a:spcAft>
+                <a:spcPts val="500"/>
+              </a:spcAft>
+            </a:pPr>
+            <a:r>
+              <a:rPr sz="1600" b="0" i="0">
+                <a:solidFill>
+                  <a:srgbClr val="333D4B"/>
+                </a:solidFill>
+                <a:latin typeface="Calibri"/>
+              </a:rPr>
+              <a:t>—  Ask it to avoid idiom and phrasal verbs — "postpone" rather than "put off"</a:t>
+            </a:r>
+          </a:p>
+          <a:p>
+            <a:pPr lvl="1">
+              <a:lnSpc>
+                <a:spcPct val="115000"/>
+              </a:lnSpc>
+              <a:spcAft>
+                <a:spcPts val="500"/>
+              </a:spcAft>
+            </a:pPr>
+            <a:r>
+              <a:rPr sz="1600" b="0" i="0">
+                <a:solidFill>
+                  <a:srgbClr val="333D4B"/>
+                </a:solidFill>
+                <a:latin typeface="Calibri"/>
+              </a:rPr>
+              <a:t>—  Ask for the main point first, before the qualifications</a:t>
+            </a:r>
+          </a:p>
+          <a:p>
+            <a:pPr>
+              <a:lnSpc>
+                <a:spcPct val="115000"/>
+              </a:lnSpc>
+              <a:spcAft>
+                <a:spcPts val="1000"/>
+              </a:spcAft>
+            </a:pPr>
+          </a:p>
+          <a:p>
+            <a:pPr>
+              <a:lnSpc>
+                <a:spcPct val="115000"/>
+              </a:lnSpc>
+              <a:spcAft>
+                <a:spcPts val="1000"/>
+              </a:spcAft>
+            </a:pPr>
+            <a:r>
+              <a:rPr sz="1900" b="1" i="0">
+                <a:solidFill>
+                  <a:srgbClr val="1F2937"/>
+                </a:solidFill>
+                <a:latin typeface="Calibri"/>
+              </a:rPr>
+              <a:t>•  A useful instruction:</a:t>
+            </a:r>
+          </a:p>
+          <a:p>
+            <a:pPr lvl="1">
+              <a:lnSpc>
+                <a:spcPct val="115000"/>
+              </a:lnSpc>
+              <a:spcAft>
+                <a:spcPts val="500"/>
+              </a:spcAft>
+            </a:pPr>
+            <a:r>
+              <a:rPr sz="1600" b="0" i="0">
+                <a:solidFill>
+                  <a:srgbClr val="333D4B"/>
+                </a:solidFill>
+                <a:latin typeface="Calibri"/>
+              </a:rPr>
+              <a:t>—  "The reader is a competent professional reading in their second language. Avoid idiom. One idea per sentence."</a:t>
+            </a:r>
+          </a:p>
+          <a:p>
+            <a:pPr lvl="1">
+              <a:lnSpc>
+                <a:spcPct val="115000"/>
+              </a:lnSpc>
+              <a:spcAft>
+                <a:spcPts val="500"/>
+              </a:spcAft>
+            </a:pPr>
+            <a:r>
+              <a:rPr sz="1600" b="0" i="0">
+                <a:solidFill>
+                  <a:srgbClr val="333D4B"/>
+                </a:solidFill>
+                <a:latin typeface="Calibri"/>
+              </a:rPr>
+              <a:t>—  Note what this is not: it is not simplification, and it is not writing down to anyone.</a:t>
+            </a:r>
+          </a:p>
+        </p:txBody>
+      </p:sp>
+      <p:sp>
+        <p:nvSpPr>
+          <p:cNvPr id="5" name="TextBox 4"/>
           <p:cNvSpPr txBox="1"/>
           <p:nvPr/>
         </p:nvSpPr>
         <p:spPr>
           <a:xfrm>
-            <a:off x="1280160" y="3200400"/>
-            <a:ext cx="10058400" cy="1097280"/>
+            <a:off x="777240" y="6355080"/>
+            <a:ext cx="10637215" cy="274320"/>
           </a:xfrm>
           <a:prstGeom prst="rect">
             <a:avLst/>
@@ -8772,13 +9737,48 @@
           <a:lstStyle/>
           <a:p>
             <a:r>
-              <a:rPr sz="3400" b="1" i="0">
-                <a:solidFill>
-                  <a:srgbClr val="1F2937"/>
-                </a:solidFill>
-                <a:latin typeface="Calibri Light"/>
-              </a:rPr>
-              <a:t>Activity: The Tone Ladder</a:t>
+              <a:rPr sz="1000" b="0" i="0">
+                <a:solidFill>
+                  <a:srgbClr val="6B7787"/>
+                </a:solidFill>
+                <a:latin typeface="Calibri"/>
+              </a:rPr>
+              <a:t>Week 5  ·  Prompt Engineering and Large Language Models</a:t>
+            </a:r>
+          </a:p>
+        </p:txBody>
+      </p:sp>
+      <p:sp>
+        <p:nvSpPr>
+          <p:cNvPr id="6" name="TextBox 5"/>
+          <p:cNvSpPr txBox="1"/>
+          <p:nvPr/>
+        </p:nvSpPr>
+        <p:spPr>
+          <a:xfrm>
+            <a:off x="10500055" y="6355080"/>
+            <a:ext cx="914400" cy="274320"/>
+          </a:xfrm>
+          <a:prstGeom prst="rect">
+            <a:avLst/>
+          </a:prstGeom>
+          <a:noFill/>
+        </p:spPr>
+        <p:txBody>
+          <a:bodyPr wrap="square" lIns="0" rIns="0" tIns="0" bIns="0">
+            <a:spAutoFit/>
+          </a:bodyPr>
+          <a:lstStyle/>
+          <a:p>
+            <a:pPr algn="r"/>
+            <a:r>
+              <a:rPr sz="1000" b="0" i="0">
+                <a:solidFill>
+                  <a:srgbClr val="6B7787"/>
+                </a:solidFill>
+                <a:latin typeface="Calibri"/>
+              </a:rPr>
+              <a:t>16</a:t>
             </a:r>
           </a:p>
         </p:txBody>
@@ -8810,7 +9810,7 @@
         <p:spPr>
           <a:xfrm>
             <a:off x="777240" y="566928"/>
-            <a:ext cx="10637215" cy="365760"/>
+            <a:ext cx="10637215" cy="822960"/>
           </a:xfrm>
           <a:prstGeom prst="rect">
             <a:avLst/>
@@ -8824,67 +9824,33 @@
           <a:lstStyle/>
           <a:p>
             <a:r>
-              <a:rPr sz="1300" b="1" i="0">
-                <a:solidFill>
-                  <a:srgbClr val="B45309"/>
-                </a:solidFill>
-                <a:latin typeface="Calibri"/>
-              </a:rPr>
-              <a:t>IN-CLASS ACTIVITY  ·  10 MINUTES</a:t>
-            </a:r>
-          </a:p>
-        </p:txBody>
-      </p:sp>
-      <p:sp>
-        <p:nvSpPr>
-          <p:cNvPr id="3" name="TextBox 2"/>
-          <p:cNvSpPr txBox="1"/>
+              <a:rPr sz="3000" b="1" i="0">
+                <a:solidFill>
+                  <a:srgbClr val="1F2937"/>
+                </a:solidFill>
+                <a:latin typeface="Calibri Light"/>
+              </a:rPr>
+              <a:t>When Not to Over-Specify</a:t>
+            </a:r>
+          </a:p>
+        </p:txBody>
+      </p:sp>
+      <p:sp>
+        <p:nvSpPr>
+          <p:cNvPr id="3" name="Rectangle 2"/>
+          <p:cNvSpPr/>
           <p:nvPr/>
         </p:nvSpPr>
         <p:spPr>
           <a:xfrm>
-            <a:off x="777240" y="960120"/>
-            <a:ext cx="10637215" cy="731520"/>
+            <a:off x="777240" y="1417320"/>
+            <a:ext cx="1051560" cy="38100"/>
           </a:xfrm>
           <a:prstGeom prst="rect">
             <a:avLst/>
           </a:prstGeom>
-          <a:noFill/>
-        </p:spPr>
-        <p:txBody>
-          <a:bodyPr wrap="square" lIns="0" rIns="0" tIns="0" bIns="0">
-            <a:spAutoFit/>
-          </a:bodyPr>
-          <a:lstStyle/>
-          <a:p>
-            <a:r>
-              <a:rPr sz="3000" b="1" i="0">
-                <a:solidFill>
-                  <a:srgbClr val="1F2937"/>
-                </a:solidFill>
-                <a:latin typeface="Calibri Light"/>
-              </a:rPr>
-              <a:t>The Tone Ladder</a:t>
-            </a:r>
-          </a:p>
-        </p:txBody>
-      </p:sp>
-      <p:sp>
-        <p:nvSpPr>
-          <p:cNvPr id="4" name="Rectangle 3"/>
-          <p:cNvSpPr/>
-          <p:nvPr/>
-        </p:nvSpPr>
-        <p:spPr>
-          <a:xfrm>
-            <a:off x="777240" y="1783080"/>
-            <a:ext cx="1051560" cy="38100"/>
-          </a:xfrm>
-          <a:prstGeom prst="rect">
-            <a:avLst/>
-          </a:prstGeom>
           <a:solidFill>
-            <a:srgbClr val="B45309"/>
+            <a:srgbClr val="0F766E"/>
           </a:solidFill>
           <a:ln>
             <a:noFill/>
@@ -8915,14 +9881,14 @@
       </p:sp>
       <p:sp>
         <p:nvSpPr>
-          <p:cNvPr id="5" name="TextBox 4"/>
+          <p:cNvPr id="4" name="TextBox 3"/>
           <p:cNvSpPr txBox="1"/>
           <p:nvPr/>
         </p:nvSpPr>
         <p:spPr>
           <a:xfrm>
-            <a:off x="777240" y="2148840"/>
-            <a:ext cx="10637215" cy="3931920"/>
+            <a:off x="777240" y="1783080"/>
+            <a:ext cx="10637215" cy="4343400"/>
           </a:xfrm>
           <a:prstGeom prst="rect">
             <a:avLst/>
@@ -8944,14 +9910,24 @@
               </a:spcAft>
             </a:pPr>
             <a:r>
-              <a:rPr sz="1900" b="1" i="0">
+              <a:rPr sz="1900" b="0" i="0">
                 <a:solidFill>
                   <a:srgbClr val="1F2937"/>
                 </a:solidFill>
                 <a:latin typeface="Calibri"/>
               </a:rPr>
-              <a:t>•  The situation:</a:t>
-            </a:r>
+              <a:t>•  Every constraint narrows the output. Enough of them and you narrow it to something useless.</a:t>
+            </a:r>
+          </a:p>
+          <a:p>
+            <a:pPr>
+              <a:lnSpc>
+                <a:spcPct val="115000"/>
+              </a:lnSpc>
+              <a:spcAft>
+                <a:spcPts val="1000"/>
+              </a:spcAft>
+            </a:pPr>
           </a:p>
           <a:p>
             <a:pPr lvl="1">
@@ -8969,7 +9945,45 @@
                 </a:solidFill>
                 <a:latin typeface="Calibri"/>
               </a:rPr>
-              <a:t>—  A patient has missed two appointments. You need to contact them.</a:t>
+              <a:t>—  Fifteen simultaneous constraints tend to produce cautious, hedged, lifeless text</a:t>
+            </a:r>
+          </a:p>
+          <a:p>
+            <a:pPr lvl="1">
+              <a:lnSpc>
+                <a:spcPct val="115000"/>
+              </a:lnSpc>
+              <a:spcAft>
+                <a:spcPts val="500"/>
+              </a:spcAft>
+            </a:pPr>
+            <a:r>
+              <a:rPr sz="1600" b="0" i="0">
+                <a:solidFill>
+                  <a:srgbClr val="333D4B"/>
+                </a:solidFill>
+                <a:latin typeface="Calibri"/>
+              </a:rPr>
+              <a:t>—  Conflicting constraints — "be comprehensive" and "under 100 words" — force an arbitrary choice you did not make</a:t>
+            </a:r>
+          </a:p>
+          <a:p>
+            <a:pPr lvl="1">
+              <a:lnSpc>
+                <a:spcPct val="115000"/>
+              </a:lnSpc>
+              <a:spcAft>
+                <a:spcPts val="500"/>
+              </a:spcAft>
+            </a:pPr>
+            <a:r>
+              <a:rPr sz="1600" b="0" i="0">
+                <a:solidFill>
+                  <a:srgbClr val="333D4B"/>
+                </a:solidFill>
+                <a:latin typeface="Calibri"/>
+              </a:rPr>
+              <a:t>—  Over-specifying format can suppress something you would have wanted to see</a:t>
             </a:r>
           </a:p>
           <a:p>
@@ -8998,7 +10012,7 @@
                 </a:solidFill>
                 <a:latin typeface="Calibri"/>
               </a:rPr>
-              <a:t>•  1.  Write the same message at three points on a ladder.</a:t>
+              <a:t>•  Practical guide:</a:t>
             </a:r>
           </a:p>
           <a:p>
@@ -9017,71 +10031,14 @@
                 </a:solidFill>
                 <a:latin typeface="Calibri"/>
               </a:rPr>
-              <a:t>—  Rung 1: warm and no pressure.  Rung 2: neutral and factual.  Rung 3: firm, with consequences.</a:t>
-            </a:r>
-          </a:p>
-          <a:p>
-            <a:pPr>
-              <a:lnSpc>
-                <a:spcPct val="115000"/>
-              </a:lnSpc>
-              <a:spcAft>
-                <a:spcPts val="1000"/>
-              </a:spcAft>
-            </a:pPr>
-            <a:r>
-              <a:rPr sz="1900" b="1" i="0">
-                <a:solidFill>
-                  <a:srgbClr val="1F2937"/>
-                </a:solidFill>
-                <a:latin typeface="Calibri"/>
-              </a:rPr>
-              <a:t>•  2.  For each rung, write down the behaviours — not the adjectives.</a:t>
-            </a:r>
-          </a:p>
-          <a:p>
-            <a:pPr lvl="1">
-              <a:lnSpc>
-                <a:spcPct val="115000"/>
-              </a:lnSpc>
-              <a:spcAft>
-                <a:spcPts val="500"/>
-              </a:spcAft>
-            </a:pPr>
-            <a:r>
-              <a:rPr sz="1600" b="0" i="0">
-                <a:solidFill>
-                  <a:srgbClr val="333D4B"/>
-                </a:solidFill>
-                <a:latin typeface="Calibri"/>
-              </a:rPr>
-              <a:t>—  What does the text actually do differently? Sentence length? Opening? What comes first?</a:t>
-            </a:r>
-          </a:p>
-          <a:p>
-            <a:pPr>
-              <a:lnSpc>
-                <a:spcPct val="115000"/>
-              </a:lnSpc>
-              <a:spcAft>
-                <a:spcPts val="1000"/>
-              </a:spcAft>
-            </a:pPr>
-            <a:r>
-              <a:rPr sz="1900" b="1" i="0">
-                <a:solidFill>
-                  <a:srgbClr val="1F2937"/>
-                </a:solidFill>
-                <a:latin typeface="Calibri"/>
-              </a:rPr>
-              <a:t>•  3.  If you have a device, generate all three and compare with yours.</a:t>
-            </a:r>
-          </a:p>
-        </p:txBody>
-      </p:sp>
-      <p:sp>
-        <p:nvSpPr>
-          <p:cNvPr id="6" name="TextBox 5"/>
+              <a:t>—  Three or four targeted constraints beat fifteen. Add them as problems appear, rather than in advance.</a:t>
+            </a:r>
+          </a:p>
+        </p:txBody>
+      </p:sp>
+      <p:sp>
+        <p:nvSpPr>
+          <p:cNvPr id="5" name="TextBox 4"/>
           <p:cNvSpPr txBox="1"/>
           <p:nvPr/>
         </p:nvSpPr>
@@ -9115,7 +10072,7 @@
       </p:sp>
       <p:sp>
         <p:nvSpPr>
-          <p:cNvPr id="7" name="TextBox 6"/>
+          <p:cNvPr id="6" name="TextBox 5"/>
           <p:cNvSpPr txBox="1"/>
           <p:nvPr/>
         </p:nvSpPr>
@@ -9195,7 +10152,7 @@
                 </a:solidFill>
                 <a:latin typeface="Calibri Light"/>
               </a:rPr>
-              <a:t>What Moves Between the Rungs</a:t>
+              <a:t>One Source, Several Audiences</a:t>
             </a:r>
           </a:p>
         </p:txBody>
@@ -9246,542 +10203,14 @@
       </p:sp>
       <p:sp>
         <p:nvSpPr>
-          <p:cNvPr id="4" name="Rounded Rectangle 3"/>
-          <p:cNvSpPr/>
-          <p:nvPr/>
-        </p:nvSpPr>
-        <p:spPr>
-          <a:xfrm>
-            <a:off x="777240" y="2057400"/>
-            <a:ext cx="3301898" cy="3200400"/>
-          </a:xfrm>
-          <a:prstGeom prst="roundRect">
-            <a:avLst>
-              <a:gd name="adj" fmla="val 10000"/>
-            </a:avLst>
-          </a:prstGeom>
-          <a:solidFill>
-            <a:srgbClr val="F1F5F9"/>
-          </a:solidFill>
-          <a:ln w="15875">
-            <a:solidFill>
-              <a:srgbClr val="D3DDE6"/>
-            </a:solidFill>
-          </a:ln>
-          <a:effectLst/>
-        </p:spPr>
-        <p:style>
-          <a:lnRef idx="1">
-            <a:schemeClr val="accent1"/>
-          </a:lnRef>
-          <a:fillRef idx="3">
-            <a:schemeClr val="accent1"/>
-          </a:fillRef>
-          <a:effectRef idx="2">
-            <a:schemeClr val="accent1"/>
-          </a:effectRef>
-          <a:fontRef idx="minor">
-            <a:schemeClr val="lt1"/>
-          </a:fontRef>
-        </p:style>
-        <p:txBody>
-          <a:bodyPr rtlCol="0" anchor="ctr"/>
-          <a:lstStyle/>
-          <a:p>
-            <a:pPr algn="ctr"/>
-          </a:p>
-        </p:txBody>
-      </p:sp>
-      <p:sp>
-        <p:nvSpPr>
-          <p:cNvPr id="5" name="Rectangle 4"/>
-          <p:cNvSpPr/>
-          <p:nvPr/>
-        </p:nvSpPr>
-        <p:spPr>
-          <a:xfrm>
-            <a:off x="978408" y="2331720"/>
-            <a:ext cx="640080" cy="38100"/>
-          </a:xfrm>
-          <a:prstGeom prst="rect">
-            <a:avLst/>
-          </a:prstGeom>
-          <a:solidFill>
-            <a:srgbClr val="0F766E"/>
-          </a:solidFill>
-          <a:ln>
-            <a:noFill/>
-          </a:ln>
-          <a:effectLst/>
-        </p:spPr>
-        <p:style>
-          <a:lnRef idx="1">
-            <a:schemeClr val="accent1"/>
-          </a:lnRef>
-          <a:fillRef idx="3">
-            <a:schemeClr val="accent1"/>
-          </a:fillRef>
-          <a:effectRef idx="2">
-            <a:schemeClr val="accent1"/>
-          </a:effectRef>
-          <a:fontRef idx="minor">
-            <a:schemeClr val="lt1"/>
-          </a:fontRef>
-        </p:style>
-        <p:txBody>
-          <a:bodyPr rtlCol="0" anchor="ctr"/>
-          <a:lstStyle/>
-          <a:p>
-            <a:pPr algn="ctr"/>
-          </a:p>
-        </p:txBody>
-      </p:sp>
-      <p:sp>
-        <p:nvSpPr>
-          <p:cNvPr id="6" name="TextBox 5"/>
+          <p:cNvPr id="4" name="TextBox 3"/>
           <p:cNvSpPr txBox="1"/>
           <p:nvPr/>
         </p:nvSpPr>
         <p:spPr>
           <a:xfrm>
-            <a:off x="978408" y="2560320"/>
-            <a:ext cx="2899562" cy="640080"/>
-          </a:xfrm>
-          <a:prstGeom prst="rect">
-            <a:avLst/>
-          </a:prstGeom>
-          <a:noFill/>
-        </p:spPr>
-        <p:txBody>
-          <a:bodyPr wrap="square" lIns="0" rIns="0" tIns="0" bIns="0" anchor="t">
-            <a:spAutoFit/>
-          </a:bodyPr>
-          <a:lstStyle/>
-          <a:p>
-            <a:pPr algn="l">
-              <a:lnSpc>
-                <a:spcPct val="105000"/>
-              </a:lnSpc>
-              <a:spcAft>
-                <a:spcPts val="200"/>
-              </a:spcAft>
-            </a:pPr>
-            <a:r>
-              <a:rPr sz="1800" b="1" i="0">
-                <a:solidFill>
-                  <a:srgbClr val="1F2937"/>
-                </a:solidFill>
-                <a:latin typeface="Calibri"/>
-              </a:rPr>
-              <a:t>What comes first</a:t>
-            </a:r>
-          </a:p>
-        </p:txBody>
-      </p:sp>
-      <p:sp>
-        <p:nvSpPr>
-          <p:cNvPr id="7" name="TextBox 6"/>
-          <p:cNvSpPr txBox="1"/>
-          <p:nvPr/>
-        </p:nvSpPr>
-        <p:spPr>
-          <a:xfrm>
-            <a:off x="978408" y="3246120"/>
-            <a:ext cx="2899562" cy="1737360"/>
-          </a:xfrm>
-          <a:prstGeom prst="rect">
-            <a:avLst/>
-          </a:prstGeom>
-          <a:noFill/>
-        </p:spPr>
-        <p:txBody>
-          <a:bodyPr wrap="square" lIns="0" rIns="0" tIns="0" bIns="0" anchor="t">
-            <a:spAutoFit/>
-          </a:bodyPr>
-          <a:lstStyle/>
-          <a:p>
-            <a:pPr algn="l">
-              <a:lnSpc>
-                <a:spcPct val="105000"/>
-              </a:lnSpc>
-              <a:spcAft>
-                <a:spcPts val="200"/>
-              </a:spcAft>
-            </a:pPr>
-            <a:r>
-              <a:rPr sz="1350" b="0" i="0">
-                <a:solidFill>
-                  <a:srgbClr val="333D4B"/>
-                </a:solidFill>
-                <a:latin typeface="Calibri"/>
-              </a:rPr>
-              <a:t>Warm opens with the person — "we hope you are well". Firm opens with the fact — "you have missed two appointments". Ordering carries more tone than vocabulary does.</a:t>
-            </a:r>
-          </a:p>
-        </p:txBody>
-      </p:sp>
-      <p:sp>
-        <p:nvSpPr>
-          <p:cNvPr id="8" name="Rounded Rectangle 7"/>
-          <p:cNvSpPr/>
-          <p:nvPr/>
-        </p:nvSpPr>
-        <p:spPr>
-          <a:xfrm>
-            <a:off x="4444898" y="2057400"/>
-            <a:ext cx="3301898" cy="3200400"/>
-          </a:xfrm>
-          <a:prstGeom prst="roundRect">
-            <a:avLst>
-              <a:gd name="adj" fmla="val 10000"/>
-            </a:avLst>
-          </a:prstGeom>
-          <a:solidFill>
-            <a:srgbClr val="F1F5F9"/>
-          </a:solidFill>
-          <a:ln w="15875">
-            <a:solidFill>
-              <a:srgbClr val="D3DDE6"/>
-            </a:solidFill>
-          </a:ln>
-          <a:effectLst/>
-        </p:spPr>
-        <p:style>
-          <a:lnRef idx="1">
-            <a:schemeClr val="accent1"/>
-          </a:lnRef>
-          <a:fillRef idx="3">
-            <a:schemeClr val="accent1"/>
-          </a:fillRef>
-          <a:effectRef idx="2">
-            <a:schemeClr val="accent1"/>
-          </a:effectRef>
-          <a:fontRef idx="minor">
-            <a:schemeClr val="lt1"/>
-          </a:fontRef>
-        </p:style>
-        <p:txBody>
-          <a:bodyPr rtlCol="0" anchor="ctr"/>
-          <a:lstStyle/>
-          <a:p>
-            <a:pPr algn="ctr"/>
-          </a:p>
-        </p:txBody>
-      </p:sp>
-      <p:sp>
-        <p:nvSpPr>
-          <p:cNvPr id="9" name="Rectangle 8"/>
-          <p:cNvSpPr/>
-          <p:nvPr/>
-        </p:nvSpPr>
-        <p:spPr>
-          <a:xfrm>
-            <a:off x="4646066" y="2331720"/>
-            <a:ext cx="640080" cy="38100"/>
-          </a:xfrm>
-          <a:prstGeom prst="rect">
-            <a:avLst/>
-          </a:prstGeom>
-          <a:solidFill>
-            <a:srgbClr val="0F766E"/>
-          </a:solidFill>
-          <a:ln>
-            <a:noFill/>
-          </a:ln>
-          <a:effectLst/>
-        </p:spPr>
-        <p:style>
-          <a:lnRef idx="1">
-            <a:schemeClr val="accent1"/>
-          </a:lnRef>
-          <a:fillRef idx="3">
-            <a:schemeClr val="accent1"/>
-          </a:fillRef>
-          <a:effectRef idx="2">
-            <a:schemeClr val="accent1"/>
-          </a:effectRef>
-          <a:fontRef idx="minor">
-            <a:schemeClr val="lt1"/>
-          </a:fontRef>
-        </p:style>
-        <p:txBody>
-          <a:bodyPr rtlCol="0" anchor="ctr"/>
-          <a:lstStyle/>
-          <a:p>
-            <a:pPr algn="ctr"/>
-          </a:p>
-        </p:txBody>
-      </p:sp>
-      <p:sp>
-        <p:nvSpPr>
-          <p:cNvPr id="10" name="TextBox 9"/>
-          <p:cNvSpPr txBox="1"/>
-          <p:nvPr/>
-        </p:nvSpPr>
-        <p:spPr>
-          <a:xfrm>
-            <a:off x="4646066" y="2560320"/>
-            <a:ext cx="2899562" cy="640080"/>
-          </a:xfrm>
-          <a:prstGeom prst="rect">
-            <a:avLst/>
-          </a:prstGeom>
-          <a:noFill/>
-        </p:spPr>
-        <p:txBody>
-          <a:bodyPr wrap="square" lIns="0" rIns="0" tIns="0" bIns="0" anchor="t">
-            <a:spAutoFit/>
-          </a:bodyPr>
-          <a:lstStyle/>
-          <a:p>
-            <a:pPr algn="l">
-              <a:lnSpc>
-                <a:spcPct val="105000"/>
-              </a:lnSpc>
-              <a:spcAft>
-                <a:spcPts val="200"/>
-              </a:spcAft>
-            </a:pPr>
-            <a:r>
-              <a:rPr sz="1800" b="1" i="0">
-                <a:solidFill>
-                  <a:srgbClr val="1F2937"/>
-                </a:solidFill>
-                <a:latin typeface="Calibri"/>
-              </a:rPr>
-              <a:t>Who is the subject</a:t>
-            </a:r>
-          </a:p>
-        </p:txBody>
-      </p:sp>
-      <p:sp>
-        <p:nvSpPr>
-          <p:cNvPr id="11" name="TextBox 10"/>
-          <p:cNvSpPr txBox="1"/>
-          <p:nvPr/>
-        </p:nvSpPr>
-        <p:spPr>
-          <a:xfrm>
-            <a:off x="4646066" y="3246120"/>
-            <a:ext cx="2899562" cy="1737360"/>
-          </a:xfrm>
-          <a:prstGeom prst="rect">
-            <a:avLst/>
-          </a:prstGeom>
-          <a:noFill/>
-        </p:spPr>
-        <p:txBody>
-          <a:bodyPr wrap="square" lIns="0" rIns="0" tIns="0" bIns="0" anchor="t">
-            <a:spAutoFit/>
-          </a:bodyPr>
-          <a:lstStyle/>
-          <a:p>
-            <a:pPr algn="l">
-              <a:lnSpc>
-                <a:spcPct val="105000"/>
-              </a:lnSpc>
-              <a:spcAft>
-                <a:spcPts val="200"/>
-              </a:spcAft>
-            </a:pPr>
-            <a:r>
-              <a:rPr sz="1350" b="0" i="0">
-                <a:solidFill>
-                  <a:srgbClr val="333D4B"/>
-                </a:solidFill>
-                <a:latin typeface="Calibri"/>
-              </a:rPr>
-              <a:t>"We would love to see you" versus "You have not attended". Warm makes the institution the actor; firm makes the reader the actor. This single shift moves the tone further than any adjective.</a:t>
-            </a:r>
-          </a:p>
-        </p:txBody>
-      </p:sp>
-      <p:sp>
-        <p:nvSpPr>
-          <p:cNvPr id="12" name="Rounded Rectangle 11"/>
-          <p:cNvSpPr/>
-          <p:nvPr/>
-        </p:nvSpPr>
-        <p:spPr>
-          <a:xfrm>
-            <a:off x="8112556" y="2057400"/>
-            <a:ext cx="3301898" cy="3200400"/>
-          </a:xfrm>
-          <a:prstGeom prst="roundRect">
-            <a:avLst>
-              <a:gd name="adj" fmla="val 10000"/>
-            </a:avLst>
-          </a:prstGeom>
-          <a:solidFill>
-            <a:srgbClr val="F1F5F9"/>
-          </a:solidFill>
-          <a:ln w="15875">
-            <a:solidFill>
-              <a:srgbClr val="D3DDE6"/>
-            </a:solidFill>
-          </a:ln>
-          <a:effectLst/>
-        </p:spPr>
-        <p:style>
-          <a:lnRef idx="1">
-            <a:schemeClr val="accent1"/>
-          </a:lnRef>
-          <a:fillRef idx="3">
-            <a:schemeClr val="accent1"/>
-          </a:fillRef>
-          <a:effectRef idx="2">
-            <a:schemeClr val="accent1"/>
-          </a:effectRef>
-          <a:fontRef idx="minor">
-            <a:schemeClr val="lt1"/>
-          </a:fontRef>
-        </p:style>
-        <p:txBody>
-          <a:bodyPr rtlCol="0" anchor="ctr"/>
-          <a:lstStyle/>
-          <a:p>
-            <a:pPr algn="ctr"/>
-          </a:p>
-        </p:txBody>
-      </p:sp>
-      <p:sp>
-        <p:nvSpPr>
-          <p:cNvPr id="13" name="Rectangle 12"/>
-          <p:cNvSpPr/>
-          <p:nvPr/>
-        </p:nvSpPr>
-        <p:spPr>
-          <a:xfrm>
-            <a:off x="8313724" y="2331720"/>
-            <a:ext cx="640080" cy="38100"/>
-          </a:xfrm>
-          <a:prstGeom prst="rect">
-            <a:avLst/>
-          </a:prstGeom>
-          <a:solidFill>
-            <a:srgbClr val="0F766E"/>
-          </a:solidFill>
-          <a:ln>
-            <a:noFill/>
-          </a:ln>
-          <a:effectLst/>
-        </p:spPr>
-        <p:style>
-          <a:lnRef idx="1">
-            <a:schemeClr val="accent1"/>
-          </a:lnRef>
-          <a:fillRef idx="3">
-            <a:schemeClr val="accent1"/>
-          </a:fillRef>
-          <a:effectRef idx="2">
-            <a:schemeClr val="accent1"/>
-          </a:effectRef>
-          <a:fontRef idx="minor">
-            <a:schemeClr val="lt1"/>
-          </a:fontRef>
-        </p:style>
-        <p:txBody>
-          <a:bodyPr rtlCol="0" anchor="ctr"/>
-          <a:lstStyle/>
-          <a:p>
-            <a:pPr algn="ctr"/>
-          </a:p>
-        </p:txBody>
-      </p:sp>
-      <p:sp>
-        <p:nvSpPr>
-          <p:cNvPr id="14" name="TextBox 13"/>
-          <p:cNvSpPr txBox="1"/>
-          <p:nvPr/>
-        </p:nvSpPr>
-        <p:spPr>
-          <a:xfrm>
-            <a:off x="8313724" y="2560320"/>
-            <a:ext cx="2899562" cy="640080"/>
-          </a:xfrm>
-          <a:prstGeom prst="rect">
-            <a:avLst/>
-          </a:prstGeom>
-          <a:noFill/>
-        </p:spPr>
-        <p:txBody>
-          <a:bodyPr wrap="square" lIns="0" rIns="0" tIns="0" bIns="0" anchor="t">
-            <a:spAutoFit/>
-          </a:bodyPr>
-          <a:lstStyle/>
-          <a:p>
-            <a:pPr algn="l">
-              <a:lnSpc>
-                <a:spcPct val="105000"/>
-              </a:lnSpc>
-              <a:spcAft>
-                <a:spcPts val="200"/>
-              </a:spcAft>
-            </a:pPr>
-            <a:r>
-              <a:rPr sz="1800" b="1" i="0">
-                <a:solidFill>
-                  <a:srgbClr val="1F2937"/>
-                </a:solidFill>
-                <a:latin typeface="Calibri"/>
-              </a:rPr>
-              <a:t>What is left implicit</a:t>
-            </a:r>
-          </a:p>
-        </p:txBody>
-      </p:sp>
-      <p:sp>
-        <p:nvSpPr>
-          <p:cNvPr id="15" name="TextBox 14"/>
-          <p:cNvSpPr txBox="1"/>
-          <p:nvPr/>
-        </p:nvSpPr>
-        <p:spPr>
-          <a:xfrm>
-            <a:off x="8313724" y="3246120"/>
-            <a:ext cx="2899562" cy="1737360"/>
-          </a:xfrm>
-          <a:prstGeom prst="rect">
-            <a:avLst/>
-          </a:prstGeom>
-          <a:noFill/>
-        </p:spPr>
-        <p:txBody>
-          <a:bodyPr wrap="square" lIns="0" rIns="0" tIns="0" bIns="0" anchor="t">
-            <a:spAutoFit/>
-          </a:bodyPr>
-          <a:lstStyle/>
-          <a:p>
-            <a:pPr algn="l">
-              <a:lnSpc>
-                <a:spcPct val="105000"/>
-              </a:lnSpc>
-              <a:spcAft>
-                <a:spcPts val="200"/>
-              </a:spcAft>
-            </a:pPr>
-            <a:r>
-              <a:rPr sz="1350" b="0" i="0">
-                <a:solidFill>
-                  <a:srgbClr val="333D4B"/>
-                </a:solidFill>
-                <a:latin typeface="Calibri"/>
-              </a:rPr>
-              <a:t>Warm implies the consequence; firm states it. Neutral often states it once, without elaboration. Explicitness, not harshness, is what people read as firm.</a:t>
-            </a:r>
-          </a:p>
-        </p:txBody>
-      </p:sp>
-      <p:sp>
-        <p:nvSpPr>
-          <p:cNvPr id="16" name="TextBox 15"/>
-          <p:cNvSpPr txBox="1"/>
-          <p:nvPr/>
-        </p:nvSpPr>
-        <p:spPr>
-          <a:xfrm>
-            <a:off x="777240" y="6355080"/>
-            <a:ext cx="10637215" cy="274320"/>
+            <a:off x="777240" y="1783080"/>
+            <a:ext cx="10637215" cy="4343400"/>
           </a:xfrm>
           <a:prstGeom prst="rect">
             <a:avLst/>
@@ -9794,6 +10223,182 @@
           </a:bodyPr>
           <a:lstStyle/>
           <a:p>
+            <a:pPr>
+              <a:lnSpc>
+                <a:spcPct val="115000"/>
+              </a:lnSpc>
+              <a:spcAft>
+                <a:spcPts val="1000"/>
+              </a:spcAft>
+            </a:pPr>
+            <a:r>
+              <a:rPr sz="1900" b="0" i="0">
+                <a:solidFill>
+                  <a:srgbClr val="1F2937"/>
+                </a:solidFill>
+                <a:latin typeface="Calibri"/>
+              </a:rPr>
+              <a:t>•  A common professional need: the same content, correctly pitched to different readers</a:t>
+            </a:r>
+          </a:p>
+          <a:p>
+            <a:pPr>
+              <a:lnSpc>
+                <a:spcPct val="115000"/>
+              </a:lnSpc>
+              <a:spcAft>
+                <a:spcPts val="1000"/>
+              </a:spcAft>
+            </a:pPr>
+          </a:p>
+          <a:p>
+            <a:pPr lvl="1">
+              <a:lnSpc>
+                <a:spcPct val="115000"/>
+              </a:lnSpc>
+              <a:spcAft>
+                <a:spcPts val="500"/>
+              </a:spcAft>
+            </a:pPr>
+            <a:r>
+              <a:rPr sz="1600" b="0" i="0">
+                <a:solidFill>
+                  <a:srgbClr val="333D4B"/>
+                </a:solidFill>
+                <a:latin typeface="Calibri"/>
+              </a:rPr>
+              <a:t>—  A clinical finding → the notes, the referral letter, and the explanation to the family</a:t>
+            </a:r>
+          </a:p>
+          <a:p>
+            <a:pPr lvl="1">
+              <a:lnSpc>
+                <a:spcPct val="115000"/>
+              </a:lnSpc>
+              <a:spcAft>
+                <a:spcPts val="500"/>
+              </a:spcAft>
+            </a:pPr>
+            <a:r>
+              <a:rPr sz="1600" b="0" i="0">
+                <a:solidFill>
+                  <a:srgbClr val="333D4B"/>
+                </a:solidFill>
+                <a:latin typeface="Calibri"/>
+              </a:rPr>
+              <a:t>—  A contract review → the memo to the partner and the email to the client</a:t>
+            </a:r>
+          </a:p>
+          <a:p>
+            <a:pPr lvl="1">
+              <a:lnSpc>
+                <a:spcPct val="115000"/>
+              </a:lnSpc>
+              <a:spcAft>
+                <a:spcPts val="500"/>
+              </a:spcAft>
+            </a:pPr>
+            <a:r>
+              <a:rPr sz="1600" b="0" i="0">
+                <a:solidFill>
+                  <a:srgbClr val="333D4B"/>
+                </a:solidFill>
+                <a:latin typeface="Calibri"/>
+              </a:rPr>
+              <a:t>—  An exam result → the transcript, the report to parents, the feedback to the student</a:t>
+            </a:r>
+          </a:p>
+          <a:p>
+            <a:pPr>
+              <a:lnSpc>
+                <a:spcPct val="115000"/>
+              </a:lnSpc>
+              <a:spcAft>
+                <a:spcPts val="1000"/>
+              </a:spcAft>
+            </a:pPr>
+          </a:p>
+          <a:p>
+            <a:pPr>
+              <a:lnSpc>
+                <a:spcPct val="115000"/>
+              </a:lnSpc>
+              <a:spcAft>
+                <a:spcPts val="1000"/>
+              </a:spcAft>
+            </a:pPr>
+            <a:r>
+              <a:rPr sz="1900" b="1" i="0">
+                <a:solidFill>
+                  <a:srgbClr val="1F2937"/>
+                </a:solidFill>
+                <a:latin typeface="Calibri"/>
+              </a:rPr>
+              <a:t>•  Do them as separate turns from the same source, not as one request.</a:t>
+            </a:r>
+          </a:p>
+          <a:p>
+            <a:pPr lvl="1">
+              <a:lnSpc>
+                <a:spcPct val="115000"/>
+              </a:lnSpc>
+              <a:spcAft>
+                <a:spcPts val="500"/>
+              </a:spcAft>
+            </a:pPr>
+            <a:r>
+              <a:rPr sz="1600" b="0" i="0">
+                <a:solidFill>
+                  <a:srgbClr val="333D4B"/>
+                </a:solidFill>
+                <a:latin typeface="Calibri"/>
+              </a:rPr>
+              <a:t>—  One request produces three versions that drift towards each other</a:t>
+            </a:r>
+          </a:p>
+          <a:p>
+            <a:pPr lvl="1">
+              <a:lnSpc>
+                <a:spcPct val="115000"/>
+              </a:lnSpc>
+              <a:spcAft>
+                <a:spcPts val="500"/>
+              </a:spcAft>
+            </a:pPr>
+            <a:r>
+              <a:rPr sz="1600" b="0" i="0">
+                <a:solidFill>
+                  <a:srgbClr val="333D4B"/>
+                </a:solidFill>
+                <a:latin typeface="Calibri"/>
+              </a:rPr>
+              <a:t>—  Separate turns keep each register clean — and let you check each before sending</a:t>
+            </a:r>
+          </a:p>
+        </p:txBody>
+      </p:sp>
+      <p:sp>
+        <p:nvSpPr>
+          <p:cNvPr id="5" name="TextBox 4"/>
+          <p:cNvSpPr txBox="1"/>
+          <p:nvPr/>
+        </p:nvSpPr>
+        <p:spPr>
+          <a:xfrm>
+            <a:off x="777240" y="6355080"/>
+            <a:ext cx="10637215" cy="274320"/>
+          </a:xfrm>
+          <a:prstGeom prst="rect">
+            <a:avLst/>
+          </a:prstGeom>
+          <a:noFill/>
+        </p:spPr>
+        <p:txBody>
+          <a:bodyPr wrap="square" lIns="0" rIns="0" tIns="0" bIns="0">
+            <a:spAutoFit/>
+          </a:bodyPr>
+          <a:lstStyle/>
+          <a:p>
             <a:r>
               <a:rPr sz="1000" b="0" i="0">
                 <a:solidFill>
@@ -9808,7 +10413,7 @@
       </p:sp>
       <p:sp>
         <p:nvSpPr>
-          <p:cNvPr id="17" name="TextBox 16"/>
+          <p:cNvPr id="6" name="TextBox 5"/>
           <p:cNvSpPr txBox="1"/>
           <p:nvPr/>
         </p:nvSpPr>
@@ -9861,48 +10466,14 @@
       <p:grpSpPr/>
       <p:sp>
         <p:nvSpPr>
-          <p:cNvPr id="2" name="TextBox 1"/>
-          <p:cNvSpPr txBox="1"/>
-          <p:nvPr/>
-        </p:nvSpPr>
-        <p:spPr>
-          <a:xfrm>
-            <a:off x="777240" y="566928"/>
-            <a:ext cx="10637215" cy="822960"/>
-          </a:xfrm>
-          <a:prstGeom prst="rect">
-            <a:avLst/>
-          </a:prstGeom>
-          <a:noFill/>
-        </p:spPr>
-        <p:txBody>
-          <a:bodyPr wrap="square" lIns="0" rIns="0" tIns="0" bIns="0">
-            <a:spAutoFit/>
-          </a:bodyPr>
-          <a:lstStyle/>
-          <a:p>
-            <a:r>
-              <a:rPr sz="3000" b="1" i="0">
-                <a:solidFill>
-                  <a:srgbClr val="1F2937"/>
-                </a:solidFill>
-                <a:latin typeface="Calibri Light"/>
-              </a:rPr>
-              <a:t>Wrap-Up</a:t>
-            </a:r>
-          </a:p>
-        </p:txBody>
-      </p:sp>
-      <p:sp>
-        <p:nvSpPr>
-          <p:cNvPr id="3" name="Rectangle 2"/>
+          <p:cNvPr id="2" name="Rectangle 1"/>
           <p:cNvSpPr/>
           <p:nvPr/>
         </p:nvSpPr>
         <p:spPr>
           <a:xfrm>
-            <a:off x="777240" y="1417320"/>
-            <a:ext cx="1051560" cy="38100"/>
+            <a:off x="0" y="0"/>
+            <a:ext cx="292608" cy="6858000"/>
           </a:xfrm>
           <a:prstGeom prst="rect">
             <a:avLst/>
@@ -9939,14 +10510,48 @@
       </p:sp>
       <p:sp>
         <p:nvSpPr>
+          <p:cNvPr id="3" name="TextBox 2"/>
+          <p:cNvSpPr txBox="1"/>
+          <p:nvPr/>
+        </p:nvSpPr>
+        <p:spPr>
+          <a:xfrm>
+            <a:off x="1280160" y="2743200"/>
+            <a:ext cx="10058400" cy="457200"/>
+          </a:xfrm>
+          <a:prstGeom prst="rect">
+            <a:avLst/>
+          </a:prstGeom>
+          <a:noFill/>
+        </p:spPr>
+        <p:txBody>
+          <a:bodyPr wrap="square" lIns="0" rIns="0" tIns="0" bIns="0">
+            <a:spAutoFit/>
+          </a:bodyPr>
+          <a:lstStyle/>
+          <a:p>
+            <a:r>
+              <a:rPr sz="1400" b="1" i="0">
+                <a:solidFill>
+                  <a:srgbClr val="0F766E"/>
+                </a:solidFill>
+                <a:latin typeface="Calibri"/>
+              </a:rPr>
+              <a:t>PART 4</a:t>
+            </a:r>
+          </a:p>
+        </p:txBody>
+      </p:sp>
+      <p:sp>
+        <p:nvSpPr>
           <p:cNvPr id="4" name="TextBox 3"/>
           <p:cNvSpPr txBox="1"/>
           <p:nvPr/>
         </p:nvSpPr>
         <p:spPr>
           <a:xfrm>
-            <a:off x="777240" y="1783080"/>
-            <a:ext cx="10637215" cy="4343400"/>
+            <a:off x="1280160" y="3200400"/>
+            <a:ext cx="10058400" cy="1097280"/>
           </a:xfrm>
           <a:prstGeom prst="rect">
             <a:avLst/>
@@ -9959,215 +10564,14 @@
           </a:bodyPr>
           <a:lstStyle/>
           <a:p>
-            <a:pPr>
-              <a:lnSpc>
-                <a:spcPct val="115000"/>
-              </a:lnSpc>
-              <a:spcAft>
-                <a:spcPts val="1000"/>
-              </a:spcAft>
-            </a:pPr>
-            <a:r>
-              <a:rPr sz="1900" b="0" i="0">
+            <a:r>
+              <a:rPr sz="3400" b="1" i="0">
                 <a:solidFill>
                   <a:srgbClr val="1F2937"/>
                 </a:solidFill>
-                <a:latin typeface="Calibri"/>
-              </a:rPr>
-              <a:t>•  "Professional" describes a feeling, not a text — specify field, tenor and mode instead</a:t>
-            </a:r>
-          </a:p>
-          <a:p>
-            <a:pPr>
-              <a:lnSpc>
-                <a:spcPct val="115000"/>
-              </a:lnSpc>
-              <a:spcAft>
-                <a:spcPts val="1000"/>
-              </a:spcAft>
-            </a:pPr>
-            <a:r>
-              <a:rPr sz="1900" b="0" i="0">
-                <a:solidFill>
-                  <a:srgbClr val="1F2937"/>
-                </a:solidFill>
-                <a:latin typeface="Calibri"/>
-              </a:rPr>
-              <a:t>•  Translate tone adjectives into behaviours you can check</a:t>
-            </a:r>
-          </a:p>
-          <a:p>
-            <a:pPr>
-              <a:lnSpc>
-                <a:spcPct val="115000"/>
-              </a:lnSpc>
-              <a:spcAft>
-                <a:spcPts val="1000"/>
-              </a:spcAft>
-            </a:pPr>
-            <a:r>
-              <a:rPr sz="1900" b="0" i="0">
-                <a:solidFill>
-                  <a:srgbClr val="1F2937"/>
-                </a:solidFill>
-                <a:latin typeface="Calibri"/>
-              </a:rPr>
-              <a:t>•  Reading level is the highest-value style setting in clinical and legal communication</a:t>
-            </a:r>
-          </a:p>
-          <a:p>
-            <a:pPr>
-              <a:lnSpc>
-                <a:spcPct val="115000"/>
-              </a:lnSpc>
-              <a:spcAft>
-                <a:spcPts val="1000"/>
-              </a:spcAft>
-            </a:pPr>
-            <a:r>
-              <a:rPr sz="1900" b="1" i="0">
-                <a:solidFill>
-                  <a:srgbClr val="1F2937"/>
-                </a:solidFill>
-                <a:latin typeface="Calibri"/>
-              </a:rPr>
-              <a:t>•  Always give a fallback — make the honest answer the probable one</a:t>
-            </a:r>
-          </a:p>
-          <a:p>
-            <a:pPr>
-              <a:lnSpc>
-                <a:spcPct val="115000"/>
-              </a:lnSpc>
-              <a:spcAft>
-                <a:spcPts val="1000"/>
-              </a:spcAft>
-            </a:pPr>
-            <a:r>
-              <a:rPr sz="1900" b="0" i="0">
-                <a:solidFill>
-                  <a:srgbClr val="1F2937"/>
-                </a:solidFill>
-                <a:latin typeface="Calibri"/>
-              </a:rPr>
-              <a:t>•  Negative constraints work when they are specific and countable</a:t>
-            </a:r>
-          </a:p>
-          <a:p>
-            <a:pPr>
-              <a:lnSpc>
-                <a:spcPct val="115000"/>
-              </a:lnSpc>
-              <a:spcAft>
-                <a:spcPts val="1000"/>
-              </a:spcAft>
-            </a:pPr>
-          </a:p>
-          <a:p>
-            <a:pPr>
-              <a:lnSpc>
-                <a:spcPct val="115000"/>
-              </a:lnSpc>
-              <a:spcAft>
-                <a:spcPts val="1000"/>
-              </a:spcAft>
-            </a:pPr>
-            <a:r>
-              <a:rPr sz="1900" b="1" i="0">
-                <a:solidFill>
-                  <a:srgbClr val="1F2937"/>
-                </a:solidFill>
-                <a:latin typeface="Calibri"/>
-              </a:rPr>
-              <a:t>•  Next week:</a:t>
-            </a:r>
-          </a:p>
-          <a:p>
-            <a:pPr lvl="1">
-              <a:lnSpc>
-                <a:spcPct val="115000"/>
-              </a:lnSpc>
-              <a:spcAft>
-                <a:spcPts val="500"/>
-              </a:spcAft>
-            </a:pPr>
-            <a:r>
-              <a:rPr sz="1600" b="0" i="0">
-                <a:solidFill>
-                  <a:srgbClr val="333D4B"/>
-                </a:solidFill>
-                <a:latin typeface="Calibri"/>
-              </a:rPr>
-              <a:t>—  Building Your First Tool Without Code — you make something that runs</a:t>
-            </a:r>
-          </a:p>
-        </p:txBody>
-      </p:sp>
-      <p:sp>
-        <p:nvSpPr>
-          <p:cNvPr id="5" name="TextBox 4"/>
-          <p:cNvSpPr txBox="1"/>
-          <p:nvPr/>
-        </p:nvSpPr>
-        <p:spPr>
-          <a:xfrm>
-            <a:off x="777240" y="6355080"/>
-            <a:ext cx="10637215" cy="274320"/>
-          </a:xfrm>
-          <a:prstGeom prst="rect">
-            <a:avLst/>
-          </a:prstGeom>
-          <a:noFill/>
-        </p:spPr>
-        <p:txBody>
-          <a:bodyPr wrap="square" lIns="0" rIns="0" tIns="0" bIns="0">
-            <a:spAutoFit/>
-          </a:bodyPr>
-          <a:lstStyle/>
-          <a:p>
-            <a:r>
-              <a:rPr sz="1000" b="0" i="0">
-                <a:solidFill>
-                  <a:srgbClr val="6B7787"/>
-                </a:solidFill>
-                <a:latin typeface="Calibri"/>
-              </a:rPr>
-              <a:t>Week 5  ·  Prompt Engineering and Large Language Models</a:t>
-            </a:r>
-          </a:p>
-        </p:txBody>
-      </p:sp>
-      <p:sp>
-        <p:nvSpPr>
-          <p:cNvPr id="6" name="TextBox 5"/>
-          <p:cNvSpPr txBox="1"/>
-          <p:nvPr/>
-        </p:nvSpPr>
-        <p:spPr>
-          <a:xfrm>
-            <a:off x="10500055" y="6355080"/>
-            <a:ext cx="914400" cy="274320"/>
-          </a:xfrm>
-          <a:prstGeom prst="rect">
-            <a:avLst/>
-          </a:prstGeom>
-          <a:noFill/>
-        </p:spPr>
-        <p:txBody>
-          <a:bodyPr wrap="square" lIns="0" rIns="0" tIns="0" bIns="0">
-            <a:spAutoFit/>
-          </a:bodyPr>
-          <a:lstStyle/>
-          <a:p>
-            <a:pPr algn="r"/>
-            <a:r>
-              <a:rPr sz="1000" b="0" i="0">
-                <a:solidFill>
-                  <a:srgbClr val="6B7787"/>
-                </a:solidFill>
-                <a:latin typeface="Calibri"/>
-              </a:rPr>
-              <a:t>19</a:t>
+                <a:latin typeface="Calibri Light"/>
+              </a:rPr>
+              <a:t>Activity: The Tone Ladder</a:t>
             </a:r>
           </a:p>
         </p:txBody>
@@ -10502,6 +10906,1395 @@
 </file>
 
 <file path=ppt/slides/slide20.xml><?xml version="1.0" encoding="utf-8"?>
+<p:sld xmlns:a="http://schemas.openxmlformats.org/drawingml/2006/main" xmlns:p="http://schemas.openxmlformats.org/presentationml/2006/main" xmlns:r="http://schemas.openxmlformats.org/officeDocument/2006/relationships">
+  <p:cSld>
+    <p:spTree>
+      <p:nvGrpSpPr>
+        <p:cNvPr id="1" name=""/>
+        <p:cNvGrpSpPr/>
+        <p:nvPr/>
+      </p:nvGrpSpPr>
+      <p:grpSpPr/>
+      <p:sp>
+        <p:nvSpPr>
+          <p:cNvPr id="2" name="TextBox 1"/>
+          <p:cNvSpPr txBox="1"/>
+          <p:nvPr/>
+        </p:nvSpPr>
+        <p:spPr>
+          <a:xfrm>
+            <a:off x="777240" y="566928"/>
+            <a:ext cx="10637215" cy="365760"/>
+          </a:xfrm>
+          <a:prstGeom prst="rect">
+            <a:avLst/>
+          </a:prstGeom>
+          <a:noFill/>
+        </p:spPr>
+        <p:txBody>
+          <a:bodyPr wrap="square" lIns="0" rIns="0" tIns="0" bIns="0">
+            <a:spAutoFit/>
+          </a:bodyPr>
+          <a:lstStyle/>
+          <a:p>
+            <a:r>
+              <a:rPr sz="1300" b="1" i="0">
+                <a:solidFill>
+                  <a:srgbClr val="B45309"/>
+                </a:solidFill>
+                <a:latin typeface="Calibri"/>
+              </a:rPr>
+              <a:t>IN-CLASS ACTIVITY  ·  10 MINUTES</a:t>
+            </a:r>
+          </a:p>
+        </p:txBody>
+      </p:sp>
+      <p:sp>
+        <p:nvSpPr>
+          <p:cNvPr id="3" name="TextBox 2"/>
+          <p:cNvSpPr txBox="1"/>
+          <p:nvPr/>
+        </p:nvSpPr>
+        <p:spPr>
+          <a:xfrm>
+            <a:off x="777240" y="960120"/>
+            <a:ext cx="10637215" cy="731520"/>
+          </a:xfrm>
+          <a:prstGeom prst="rect">
+            <a:avLst/>
+          </a:prstGeom>
+          <a:noFill/>
+        </p:spPr>
+        <p:txBody>
+          <a:bodyPr wrap="square" lIns="0" rIns="0" tIns="0" bIns="0">
+            <a:spAutoFit/>
+          </a:bodyPr>
+          <a:lstStyle/>
+          <a:p>
+            <a:r>
+              <a:rPr sz="3000" b="1" i="0">
+                <a:solidFill>
+                  <a:srgbClr val="1F2937"/>
+                </a:solidFill>
+                <a:latin typeface="Calibri Light"/>
+              </a:rPr>
+              <a:t>The Tone Ladder</a:t>
+            </a:r>
+          </a:p>
+        </p:txBody>
+      </p:sp>
+      <p:sp>
+        <p:nvSpPr>
+          <p:cNvPr id="4" name="Rectangle 3"/>
+          <p:cNvSpPr/>
+          <p:nvPr/>
+        </p:nvSpPr>
+        <p:spPr>
+          <a:xfrm>
+            <a:off x="777240" y="1783080"/>
+            <a:ext cx="1051560" cy="38100"/>
+          </a:xfrm>
+          <a:prstGeom prst="rect">
+            <a:avLst/>
+          </a:prstGeom>
+          <a:solidFill>
+            <a:srgbClr val="B45309"/>
+          </a:solidFill>
+          <a:ln>
+            <a:noFill/>
+          </a:ln>
+          <a:effectLst/>
+        </p:spPr>
+        <p:style>
+          <a:lnRef idx="1">
+            <a:schemeClr val="accent1"/>
+          </a:lnRef>
+          <a:fillRef idx="3">
+            <a:schemeClr val="accent1"/>
+          </a:fillRef>
+          <a:effectRef idx="2">
+            <a:schemeClr val="accent1"/>
+          </a:effectRef>
+          <a:fontRef idx="minor">
+            <a:schemeClr val="lt1"/>
+          </a:fontRef>
+        </p:style>
+        <p:txBody>
+          <a:bodyPr rtlCol="0" anchor="ctr"/>
+          <a:lstStyle/>
+          <a:p>
+            <a:pPr algn="ctr"/>
+          </a:p>
+        </p:txBody>
+      </p:sp>
+      <p:sp>
+        <p:nvSpPr>
+          <p:cNvPr id="5" name="TextBox 4"/>
+          <p:cNvSpPr txBox="1"/>
+          <p:nvPr/>
+        </p:nvSpPr>
+        <p:spPr>
+          <a:xfrm>
+            <a:off x="777240" y="2148840"/>
+            <a:ext cx="10637215" cy="3931920"/>
+          </a:xfrm>
+          <a:prstGeom prst="rect">
+            <a:avLst/>
+          </a:prstGeom>
+          <a:noFill/>
+        </p:spPr>
+        <p:txBody>
+          <a:bodyPr wrap="square" lIns="0" rIns="0" tIns="0" bIns="0">
+            <a:spAutoFit/>
+          </a:bodyPr>
+          <a:lstStyle/>
+          <a:p>
+            <a:pPr>
+              <a:lnSpc>
+                <a:spcPct val="115000"/>
+              </a:lnSpc>
+              <a:spcAft>
+                <a:spcPts val="1000"/>
+              </a:spcAft>
+            </a:pPr>
+            <a:r>
+              <a:rPr sz="1900" b="1" i="0">
+                <a:solidFill>
+                  <a:srgbClr val="1F2937"/>
+                </a:solidFill>
+                <a:latin typeface="Calibri"/>
+              </a:rPr>
+              <a:t>•  The situation:</a:t>
+            </a:r>
+          </a:p>
+          <a:p>
+            <a:pPr lvl="1">
+              <a:lnSpc>
+                <a:spcPct val="115000"/>
+              </a:lnSpc>
+              <a:spcAft>
+                <a:spcPts val="500"/>
+              </a:spcAft>
+            </a:pPr>
+            <a:r>
+              <a:rPr sz="1600" b="0" i="0">
+                <a:solidFill>
+                  <a:srgbClr val="333D4B"/>
+                </a:solidFill>
+                <a:latin typeface="Calibri"/>
+              </a:rPr>
+              <a:t>—  A patient has missed two appointments. You need to contact them.</a:t>
+            </a:r>
+          </a:p>
+          <a:p>
+            <a:pPr>
+              <a:lnSpc>
+                <a:spcPct val="115000"/>
+              </a:lnSpc>
+              <a:spcAft>
+                <a:spcPts val="1000"/>
+              </a:spcAft>
+            </a:pPr>
+          </a:p>
+          <a:p>
+            <a:pPr>
+              <a:lnSpc>
+                <a:spcPct val="115000"/>
+              </a:lnSpc>
+              <a:spcAft>
+                <a:spcPts val="1000"/>
+              </a:spcAft>
+            </a:pPr>
+            <a:r>
+              <a:rPr sz="1900" b="1" i="0">
+                <a:solidFill>
+                  <a:srgbClr val="1F2937"/>
+                </a:solidFill>
+                <a:latin typeface="Calibri"/>
+              </a:rPr>
+              <a:t>•  1.  Write the same message at three points on a ladder.</a:t>
+            </a:r>
+          </a:p>
+          <a:p>
+            <a:pPr lvl="1">
+              <a:lnSpc>
+                <a:spcPct val="115000"/>
+              </a:lnSpc>
+              <a:spcAft>
+                <a:spcPts val="500"/>
+              </a:spcAft>
+            </a:pPr>
+            <a:r>
+              <a:rPr sz="1600" b="0" i="0">
+                <a:solidFill>
+                  <a:srgbClr val="333D4B"/>
+                </a:solidFill>
+                <a:latin typeface="Calibri"/>
+              </a:rPr>
+              <a:t>—  Rung 1: warm and no pressure.  Rung 2: neutral and factual.  Rung 3: firm, with consequences.</a:t>
+            </a:r>
+          </a:p>
+          <a:p>
+            <a:pPr>
+              <a:lnSpc>
+                <a:spcPct val="115000"/>
+              </a:lnSpc>
+              <a:spcAft>
+                <a:spcPts val="1000"/>
+              </a:spcAft>
+            </a:pPr>
+            <a:r>
+              <a:rPr sz="1900" b="1" i="0">
+                <a:solidFill>
+                  <a:srgbClr val="1F2937"/>
+                </a:solidFill>
+                <a:latin typeface="Calibri"/>
+              </a:rPr>
+              <a:t>•  2.  For each rung, write down the behaviours — not the adjectives.</a:t>
+            </a:r>
+          </a:p>
+          <a:p>
+            <a:pPr lvl="1">
+              <a:lnSpc>
+                <a:spcPct val="115000"/>
+              </a:lnSpc>
+              <a:spcAft>
+                <a:spcPts val="500"/>
+              </a:spcAft>
+            </a:pPr>
+            <a:r>
+              <a:rPr sz="1600" b="0" i="0">
+                <a:solidFill>
+                  <a:srgbClr val="333D4B"/>
+                </a:solidFill>
+                <a:latin typeface="Calibri"/>
+              </a:rPr>
+              <a:t>—  What does the text actually do differently? Sentence length? Opening? What comes first?</a:t>
+            </a:r>
+          </a:p>
+          <a:p>
+            <a:pPr>
+              <a:lnSpc>
+                <a:spcPct val="115000"/>
+              </a:lnSpc>
+              <a:spcAft>
+                <a:spcPts val="1000"/>
+              </a:spcAft>
+            </a:pPr>
+            <a:r>
+              <a:rPr sz="1900" b="1" i="0">
+                <a:solidFill>
+                  <a:srgbClr val="1F2937"/>
+                </a:solidFill>
+                <a:latin typeface="Calibri"/>
+              </a:rPr>
+              <a:t>•  3.  If you have a device, generate all three and compare with yours.</a:t>
+            </a:r>
+          </a:p>
+        </p:txBody>
+      </p:sp>
+      <p:sp>
+        <p:nvSpPr>
+          <p:cNvPr id="6" name="TextBox 5"/>
+          <p:cNvSpPr txBox="1"/>
+          <p:nvPr/>
+        </p:nvSpPr>
+        <p:spPr>
+          <a:xfrm>
+            <a:off x="777240" y="6355080"/>
+            <a:ext cx="10637215" cy="274320"/>
+          </a:xfrm>
+          <a:prstGeom prst="rect">
+            <a:avLst/>
+          </a:prstGeom>
+          <a:noFill/>
+        </p:spPr>
+        <p:txBody>
+          <a:bodyPr wrap="square" lIns="0" rIns="0" tIns="0" bIns="0">
+            <a:spAutoFit/>
+          </a:bodyPr>
+          <a:lstStyle/>
+          <a:p>
+            <a:r>
+              <a:rPr sz="1000" b="0" i="0">
+                <a:solidFill>
+                  <a:srgbClr val="6B7787"/>
+                </a:solidFill>
+                <a:latin typeface="Calibri"/>
+              </a:rPr>
+              <a:t>Week 5  ·  Prompt Engineering and Large Language Models</a:t>
+            </a:r>
+          </a:p>
+        </p:txBody>
+      </p:sp>
+      <p:sp>
+        <p:nvSpPr>
+          <p:cNvPr id="7" name="TextBox 6"/>
+          <p:cNvSpPr txBox="1"/>
+          <p:nvPr/>
+        </p:nvSpPr>
+        <p:spPr>
+          <a:xfrm>
+            <a:off x="10500055" y="6355080"/>
+            <a:ext cx="914400" cy="274320"/>
+          </a:xfrm>
+          <a:prstGeom prst="rect">
+            <a:avLst/>
+          </a:prstGeom>
+          <a:noFill/>
+        </p:spPr>
+        <p:txBody>
+          <a:bodyPr wrap="square" lIns="0" rIns="0" tIns="0" bIns="0">
+            <a:spAutoFit/>
+          </a:bodyPr>
+          <a:lstStyle/>
+          <a:p>
+            <a:pPr algn="r"/>
+            <a:r>
+              <a:rPr sz="1000" b="0" i="0">
+                <a:solidFill>
+                  <a:srgbClr val="6B7787"/>
+                </a:solidFill>
+                <a:latin typeface="Calibri"/>
+              </a:rPr>
+              <a:t>20</a:t>
+            </a:r>
+          </a:p>
+        </p:txBody>
+      </p:sp>
+    </p:spTree>
+  </p:cSld>
+  <p:clrMapOvr>
+    <a:masterClrMapping/>
+  </p:clrMapOvr>
+</p:sld>
+</file>
+
+<file path=ppt/slides/slide21.xml><?xml version="1.0" encoding="utf-8"?>
+<p:sld xmlns:a="http://schemas.openxmlformats.org/drawingml/2006/main" xmlns:p="http://schemas.openxmlformats.org/presentationml/2006/main" xmlns:r="http://schemas.openxmlformats.org/officeDocument/2006/relationships">
+  <p:cSld>
+    <p:spTree>
+      <p:nvGrpSpPr>
+        <p:cNvPr id="1" name=""/>
+        <p:cNvGrpSpPr/>
+        <p:nvPr/>
+      </p:nvGrpSpPr>
+      <p:grpSpPr/>
+      <p:sp>
+        <p:nvSpPr>
+          <p:cNvPr id="2" name="TextBox 1"/>
+          <p:cNvSpPr txBox="1"/>
+          <p:nvPr/>
+        </p:nvSpPr>
+        <p:spPr>
+          <a:xfrm>
+            <a:off x="777240" y="566928"/>
+            <a:ext cx="10637215" cy="822960"/>
+          </a:xfrm>
+          <a:prstGeom prst="rect">
+            <a:avLst/>
+          </a:prstGeom>
+          <a:noFill/>
+        </p:spPr>
+        <p:txBody>
+          <a:bodyPr wrap="square" lIns="0" rIns="0" tIns="0" bIns="0">
+            <a:spAutoFit/>
+          </a:bodyPr>
+          <a:lstStyle/>
+          <a:p>
+            <a:r>
+              <a:rPr sz="3000" b="1" i="0">
+                <a:solidFill>
+                  <a:srgbClr val="1F2937"/>
+                </a:solidFill>
+                <a:latin typeface="Calibri Light"/>
+              </a:rPr>
+              <a:t>What Moves Between the Rungs</a:t>
+            </a:r>
+          </a:p>
+        </p:txBody>
+      </p:sp>
+      <p:sp>
+        <p:nvSpPr>
+          <p:cNvPr id="3" name="Rectangle 2"/>
+          <p:cNvSpPr/>
+          <p:nvPr/>
+        </p:nvSpPr>
+        <p:spPr>
+          <a:xfrm>
+            <a:off x="777240" y="1417320"/>
+            <a:ext cx="1051560" cy="38100"/>
+          </a:xfrm>
+          <a:prstGeom prst="rect">
+            <a:avLst/>
+          </a:prstGeom>
+          <a:solidFill>
+            <a:srgbClr val="0F766E"/>
+          </a:solidFill>
+          <a:ln>
+            <a:noFill/>
+          </a:ln>
+          <a:effectLst/>
+        </p:spPr>
+        <p:style>
+          <a:lnRef idx="1">
+            <a:schemeClr val="accent1"/>
+          </a:lnRef>
+          <a:fillRef idx="3">
+            <a:schemeClr val="accent1"/>
+          </a:fillRef>
+          <a:effectRef idx="2">
+            <a:schemeClr val="accent1"/>
+          </a:effectRef>
+          <a:fontRef idx="minor">
+            <a:schemeClr val="lt1"/>
+          </a:fontRef>
+        </p:style>
+        <p:txBody>
+          <a:bodyPr rtlCol="0" anchor="ctr"/>
+          <a:lstStyle/>
+          <a:p>
+            <a:pPr algn="ctr"/>
+          </a:p>
+        </p:txBody>
+      </p:sp>
+      <p:sp>
+        <p:nvSpPr>
+          <p:cNvPr id="4" name="Rounded Rectangle 3"/>
+          <p:cNvSpPr/>
+          <p:nvPr/>
+        </p:nvSpPr>
+        <p:spPr>
+          <a:xfrm>
+            <a:off x="777240" y="2057400"/>
+            <a:ext cx="3301898" cy="3200400"/>
+          </a:xfrm>
+          <a:prstGeom prst="roundRect">
+            <a:avLst>
+              <a:gd name="adj" fmla="val 10000"/>
+            </a:avLst>
+          </a:prstGeom>
+          <a:solidFill>
+            <a:srgbClr val="F1F5F9"/>
+          </a:solidFill>
+          <a:ln w="15875">
+            <a:solidFill>
+              <a:srgbClr val="D3DDE6"/>
+            </a:solidFill>
+          </a:ln>
+          <a:effectLst/>
+        </p:spPr>
+        <p:style>
+          <a:lnRef idx="1">
+            <a:schemeClr val="accent1"/>
+          </a:lnRef>
+          <a:fillRef idx="3">
+            <a:schemeClr val="accent1"/>
+          </a:fillRef>
+          <a:effectRef idx="2">
+            <a:schemeClr val="accent1"/>
+          </a:effectRef>
+          <a:fontRef idx="minor">
+            <a:schemeClr val="lt1"/>
+          </a:fontRef>
+        </p:style>
+        <p:txBody>
+          <a:bodyPr rtlCol="0" anchor="ctr"/>
+          <a:lstStyle/>
+          <a:p>
+            <a:pPr algn="ctr"/>
+          </a:p>
+        </p:txBody>
+      </p:sp>
+      <p:sp>
+        <p:nvSpPr>
+          <p:cNvPr id="5" name="Rectangle 4"/>
+          <p:cNvSpPr/>
+          <p:nvPr/>
+        </p:nvSpPr>
+        <p:spPr>
+          <a:xfrm>
+            <a:off x="978408" y="2331720"/>
+            <a:ext cx="640080" cy="38100"/>
+          </a:xfrm>
+          <a:prstGeom prst="rect">
+            <a:avLst/>
+          </a:prstGeom>
+          <a:solidFill>
+            <a:srgbClr val="0F766E"/>
+          </a:solidFill>
+          <a:ln>
+            <a:noFill/>
+          </a:ln>
+          <a:effectLst/>
+        </p:spPr>
+        <p:style>
+          <a:lnRef idx="1">
+            <a:schemeClr val="accent1"/>
+          </a:lnRef>
+          <a:fillRef idx="3">
+            <a:schemeClr val="accent1"/>
+          </a:fillRef>
+          <a:effectRef idx="2">
+            <a:schemeClr val="accent1"/>
+          </a:effectRef>
+          <a:fontRef idx="minor">
+            <a:schemeClr val="lt1"/>
+          </a:fontRef>
+        </p:style>
+        <p:txBody>
+          <a:bodyPr rtlCol="0" anchor="ctr"/>
+          <a:lstStyle/>
+          <a:p>
+            <a:pPr algn="ctr"/>
+          </a:p>
+        </p:txBody>
+      </p:sp>
+      <p:sp>
+        <p:nvSpPr>
+          <p:cNvPr id="6" name="TextBox 5"/>
+          <p:cNvSpPr txBox="1"/>
+          <p:nvPr/>
+        </p:nvSpPr>
+        <p:spPr>
+          <a:xfrm>
+            <a:off x="978408" y="2560320"/>
+            <a:ext cx="2899562" cy="640080"/>
+          </a:xfrm>
+          <a:prstGeom prst="rect">
+            <a:avLst/>
+          </a:prstGeom>
+          <a:noFill/>
+        </p:spPr>
+        <p:txBody>
+          <a:bodyPr wrap="square" lIns="0" rIns="0" tIns="0" bIns="0" anchor="t">
+            <a:spAutoFit/>
+          </a:bodyPr>
+          <a:lstStyle/>
+          <a:p>
+            <a:pPr algn="l">
+              <a:lnSpc>
+                <a:spcPct val="105000"/>
+              </a:lnSpc>
+              <a:spcAft>
+                <a:spcPts val="200"/>
+              </a:spcAft>
+            </a:pPr>
+            <a:r>
+              <a:rPr sz="1800" b="1" i="0">
+                <a:solidFill>
+                  <a:srgbClr val="1F2937"/>
+                </a:solidFill>
+                <a:latin typeface="Calibri"/>
+              </a:rPr>
+              <a:t>What comes first</a:t>
+            </a:r>
+          </a:p>
+        </p:txBody>
+      </p:sp>
+      <p:sp>
+        <p:nvSpPr>
+          <p:cNvPr id="7" name="TextBox 6"/>
+          <p:cNvSpPr txBox="1"/>
+          <p:nvPr/>
+        </p:nvSpPr>
+        <p:spPr>
+          <a:xfrm>
+            <a:off x="978408" y="3246120"/>
+            <a:ext cx="2899562" cy="1737360"/>
+          </a:xfrm>
+          <a:prstGeom prst="rect">
+            <a:avLst/>
+          </a:prstGeom>
+          <a:noFill/>
+        </p:spPr>
+        <p:txBody>
+          <a:bodyPr wrap="square" lIns="0" rIns="0" tIns="0" bIns="0" anchor="t">
+            <a:spAutoFit/>
+          </a:bodyPr>
+          <a:lstStyle/>
+          <a:p>
+            <a:pPr algn="l">
+              <a:lnSpc>
+                <a:spcPct val="105000"/>
+              </a:lnSpc>
+              <a:spcAft>
+                <a:spcPts val="200"/>
+              </a:spcAft>
+            </a:pPr>
+            <a:r>
+              <a:rPr sz="1350" b="0" i="0">
+                <a:solidFill>
+                  <a:srgbClr val="333D4B"/>
+                </a:solidFill>
+                <a:latin typeface="Calibri"/>
+              </a:rPr>
+              <a:t>Warm opens with the person — "we hope you are well". Firm opens with the fact — "you have missed two appointments". Ordering carries more tone than vocabulary does.</a:t>
+            </a:r>
+          </a:p>
+        </p:txBody>
+      </p:sp>
+      <p:sp>
+        <p:nvSpPr>
+          <p:cNvPr id="8" name="Rounded Rectangle 7"/>
+          <p:cNvSpPr/>
+          <p:nvPr/>
+        </p:nvSpPr>
+        <p:spPr>
+          <a:xfrm>
+            <a:off x="4444898" y="2057400"/>
+            <a:ext cx="3301898" cy="3200400"/>
+          </a:xfrm>
+          <a:prstGeom prst="roundRect">
+            <a:avLst>
+              <a:gd name="adj" fmla="val 10000"/>
+            </a:avLst>
+          </a:prstGeom>
+          <a:solidFill>
+            <a:srgbClr val="F1F5F9"/>
+          </a:solidFill>
+          <a:ln w="15875">
+            <a:solidFill>
+              <a:srgbClr val="D3DDE6"/>
+            </a:solidFill>
+          </a:ln>
+          <a:effectLst/>
+        </p:spPr>
+        <p:style>
+          <a:lnRef idx="1">
+            <a:schemeClr val="accent1"/>
+          </a:lnRef>
+          <a:fillRef idx="3">
+            <a:schemeClr val="accent1"/>
+          </a:fillRef>
+          <a:effectRef idx="2">
+            <a:schemeClr val="accent1"/>
+          </a:effectRef>
+          <a:fontRef idx="minor">
+            <a:schemeClr val="lt1"/>
+          </a:fontRef>
+        </p:style>
+        <p:txBody>
+          <a:bodyPr rtlCol="0" anchor="ctr"/>
+          <a:lstStyle/>
+          <a:p>
+            <a:pPr algn="ctr"/>
+          </a:p>
+        </p:txBody>
+      </p:sp>
+      <p:sp>
+        <p:nvSpPr>
+          <p:cNvPr id="9" name="Rectangle 8"/>
+          <p:cNvSpPr/>
+          <p:nvPr/>
+        </p:nvSpPr>
+        <p:spPr>
+          <a:xfrm>
+            <a:off x="4646066" y="2331720"/>
+            <a:ext cx="640080" cy="38100"/>
+          </a:xfrm>
+          <a:prstGeom prst="rect">
+            <a:avLst/>
+          </a:prstGeom>
+          <a:solidFill>
+            <a:srgbClr val="0F766E"/>
+          </a:solidFill>
+          <a:ln>
+            <a:noFill/>
+          </a:ln>
+          <a:effectLst/>
+        </p:spPr>
+        <p:style>
+          <a:lnRef idx="1">
+            <a:schemeClr val="accent1"/>
+          </a:lnRef>
+          <a:fillRef idx="3">
+            <a:schemeClr val="accent1"/>
+          </a:fillRef>
+          <a:effectRef idx="2">
+            <a:schemeClr val="accent1"/>
+          </a:effectRef>
+          <a:fontRef idx="minor">
+            <a:schemeClr val="lt1"/>
+          </a:fontRef>
+        </p:style>
+        <p:txBody>
+          <a:bodyPr rtlCol="0" anchor="ctr"/>
+          <a:lstStyle/>
+          <a:p>
+            <a:pPr algn="ctr"/>
+          </a:p>
+        </p:txBody>
+      </p:sp>
+      <p:sp>
+        <p:nvSpPr>
+          <p:cNvPr id="10" name="TextBox 9"/>
+          <p:cNvSpPr txBox="1"/>
+          <p:nvPr/>
+        </p:nvSpPr>
+        <p:spPr>
+          <a:xfrm>
+            <a:off x="4646066" y="2560320"/>
+            <a:ext cx="2899562" cy="640080"/>
+          </a:xfrm>
+          <a:prstGeom prst="rect">
+            <a:avLst/>
+          </a:prstGeom>
+          <a:noFill/>
+        </p:spPr>
+        <p:txBody>
+          <a:bodyPr wrap="square" lIns="0" rIns="0" tIns="0" bIns="0" anchor="t">
+            <a:spAutoFit/>
+          </a:bodyPr>
+          <a:lstStyle/>
+          <a:p>
+            <a:pPr algn="l">
+              <a:lnSpc>
+                <a:spcPct val="105000"/>
+              </a:lnSpc>
+              <a:spcAft>
+                <a:spcPts val="200"/>
+              </a:spcAft>
+            </a:pPr>
+            <a:r>
+              <a:rPr sz="1800" b="1" i="0">
+                <a:solidFill>
+                  <a:srgbClr val="1F2937"/>
+                </a:solidFill>
+                <a:latin typeface="Calibri"/>
+              </a:rPr>
+              <a:t>Who is the subject</a:t>
+            </a:r>
+          </a:p>
+        </p:txBody>
+      </p:sp>
+      <p:sp>
+        <p:nvSpPr>
+          <p:cNvPr id="11" name="TextBox 10"/>
+          <p:cNvSpPr txBox="1"/>
+          <p:nvPr/>
+        </p:nvSpPr>
+        <p:spPr>
+          <a:xfrm>
+            <a:off x="4646066" y="3246120"/>
+            <a:ext cx="2899562" cy="1737360"/>
+          </a:xfrm>
+          <a:prstGeom prst="rect">
+            <a:avLst/>
+          </a:prstGeom>
+          <a:noFill/>
+        </p:spPr>
+        <p:txBody>
+          <a:bodyPr wrap="square" lIns="0" rIns="0" tIns="0" bIns="0" anchor="t">
+            <a:spAutoFit/>
+          </a:bodyPr>
+          <a:lstStyle/>
+          <a:p>
+            <a:pPr algn="l">
+              <a:lnSpc>
+                <a:spcPct val="105000"/>
+              </a:lnSpc>
+              <a:spcAft>
+                <a:spcPts val="200"/>
+              </a:spcAft>
+            </a:pPr>
+            <a:r>
+              <a:rPr sz="1350" b="0" i="0">
+                <a:solidFill>
+                  <a:srgbClr val="333D4B"/>
+                </a:solidFill>
+                <a:latin typeface="Calibri"/>
+              </a:rPr>
+              <a:t>"We would love to see you" versus "You have not attended". Warm makes the institution the actor; firm makes the reader the actor. This single shift moves the tone further than any adjective.</a:t>
+            </a:r>
+          </a:p>
+        </p:txBody>
+      </p:sp>
+      <p:sp>
+        <p:nvSpPr>
+          <p:cNvPr id="12" name="Rounded Rectangle 11"/>
+          <p:cNvSpPr/>
+          <p:nvPr/>
+        </p:nvSpPr>
+        <p:spPr>
+          <a:xfrm>
+            <a:off x="8112556" y="2057400"/>
+            <a:ext cx="3301898" cy="3200400"/>
+          </a:xfrm>
+          <a:prstGeom prst="roundRect">
+            <a:avLst>
+              <a:gd name="adj" fmla="val 10000"/>
+            </a:avLst>
+          </a:prstGeom>
+          <a:solidFill>
+            <a:srgbClr val="F1F5F9"/>
+          </a:solidFill>
+          <a:ln w="15875">
+            <a:solidFill>
+              <a:srgbClr val="D3DDE6"/>
+            </a:solidFill>
+          </a:ln>
+          <a:effectLst/>
+        </p:spPr>
+        <p:style>
+          <a:lnRef idx="1">
+            <a:schemeClr val="accent1"/>
+          </a:lnRef>
+          <a:fillRef idx="3">
+            <a:schemeClr val="accent1"/>
+          </a:fillRef>
+          <a:effectRef idx="2">
+            <a:schemeClr val="accent1"/>
+          </a:effectRef>
+          <a:fontRef idx="minor">
+            <a:schemeClr val="lt1"/>
+          </a:fontRef>
+        </p:style>
+        <p:txBody>
+          <a:bodyPr rtlCol="0" anchor="ctr"/>
+          <a:lstStyle/>
+          <a:p>
+            <a:pPr algn="ctr"/>
+          </a:p>
+        </p:txBody>
+      </p:sp>
+      <p:sp>
+        <p:nvSpPr>
+          <p:cNvPr id="13" name="Rectangle 12"/>
+          <p:cNvSpPr/>
+          <p:nvPr/>
+        </p:nvSpPr>
+        <p:spPr>
+          <a:xfrm>
+            <a:off x="8313724" y="2331720"/>
+            <a:ext cx="640080" cy="38100"/>
+          </a:xfrm>
+          <a:prstGeom prst="rect">
+            <a:avLst/>
+          </a:prstGeom>
+          <a:solidFill>
+            <a:srgbClr val="0F766E"/>
+          </a:solidFill>
+          <a:ln>
+            <a:noFill/>
+          </a:ln>
+          <a:effectLst/>
+        </p:spPr>
+        <p:style>
+          <a:lnRef idx="1">
+            <a:schemeClr val="accent1"/>
+          </a:lnRef>
+          <a:fillRef idx="3">
+            <a:schemeClr val="accent1"/>
+          </a:fillRef>
+          <a:effectRef idx="2">
+            <a:schemeClr val="accent1"/>
+          </a:effectRef>
+          <a:fontRef idx="minor">
+            <a:schemeClr val="lt1"/>
+          </a:fontRef>
+        </p:style>
+        <p:txBody>
+          <a:bodyPr rtlCol="0" anchor="ctr"/>
+          <a:lstStyle/>
+          <a:p>
+            <a:pPr algn="ctr"/>
+          </a:p>
+        </p:txBody>
+      </p:sp>
+      <p:sp>
+        <p:nvSpPr>
+          <p:cNvPr id="14" name="TextBox 13"/>
+          <p:cNvSpPr txBox="1"/>
+          <p:nvPr/>
+        </p:nvSpPr>
+        <p:spPr>
+          <a:xfrm>
+            <a:off x="8313724" y="2560320"/>
+            <a:ext cx="2899562" cy="640080"/>
+          </a:xfrm>
+          <a:prstGeom prst="rect">
+            <a:avLst/>
+          </a:prstGeom>
+          <a:noFill/>
+        </p:spPr>
+        <p:txBody>
+          <a:bodyPr wrap="square" lIns="0" rIns="0" tIns="0" bIns="0" anchor="t">
+            <a:spAutoFit/>
+          </a:bodyPr>
+          <a:lstStyle/>
+          <a:p>
+            <a:pPr algn="l">
+              <a:lnSpc>
+                <a:spcPct val="105000"/>
+              </a:lnSpc>
+              <a:spcAft>
+                <a:spcPts val="200"/>
+              </a:spcAft>
+            </a:pPr>
+            <a:r>
+              <a:rPr sz="1800" b="1" i="0">
+                <a:solidFill>
+                  <a:srgbClr val="1F2937"/>
+                </a:solidFill>
+                <a:latin typeface="Calibri"/>
+              </a:rPr>
+              <a:t>What is left implicit</a:t>
+            </a:r>
+          </a:p>
+        </p:txBody>
+      </p:sp>
+      <p:sp>
+        <p:nvSpPr>
+          <p:cNvPr id="15" name="TextBox 14"/>
+          <p:cNvSpPr txBox="1"/>
+          <p:nvPr/>
+        </p:nvSpPr>
+        <p:spPr>
+          <a:xfrm>
+            <a:off x="8313724" y="3246120"/>
+            <a:ext cx="2899562" cy="1737360"/>
+          </a:xfrm>
+          <a:prstGeom prst="rect">
+            <a:avLst/>
+          </a:prstGeom>
+          <a:noFill/>
+        </p:spPr>
+        <p:txBody>
+          <a:bodyPr wrap="square" lIns="0" rIns="0" tIns="0" bIns="0" anchor="t">
+            <a:spAutoFit/>
+          </a:bodyPr>
+          <a:lstStyle/>
+          <a:p>
+            <a:pPr algn="l">
+              <a:lnSpc>
+                <a:spcPct val="105000"/>
+              </a:lnSpc>
+              <a:spcAft>
+                <a:spcPts val="200"/>
+              </a:spcAft>
+            </a:pPr>
+            <a:r>
+              <a:rPr sz="1350" b="0" i="0">
+                <a:solidFill>
+                  <a:srgbClr val="333D4B"/>
+                </a:solidFill>
+                <a:latin typeface="Calibri"/>
+              </a:rPr>
+              <a:t>Warm implies the consequence; firm states it. Neutral often states it once, without elaboration. Explicitness, not harshness, is what people read as firm.</a:t>
+            </a:r>
+          </a:p>
+        </p:txBody>
+      </p:sp>
+      <p:sp>
+        <p:nvSpPr>
+          <p:cNvPr id="16" name="TextBox 15"/>
+          <p:cNvSpPr txBox="1"/>
+          <p:nvPr/>
+        </p:nvSpPr>
+        <p:spPr>
+          <a:xfrm>
+            <a:off x="777240" y="6355080"/>
+            <a:ext cx="10637215" cy="274320"/>
+          </a:xfrm>
+          <a:prstGeom prst="rect">
+            <a:avLst/>
+          </a:prstGeom>
+          <a:noFill/>
+        </p:spPr>
+        <p:txBody>
+          <a:bodyPr wrap="square" lIns="0" rIns="0" tIns="0" bIns="0">
+            <a:spAutoFit/>
+          </a:bodyPr>
+          <a:lstStyle/>
+          <a:p>
+            <a:r>
+              <a:rPr sz="1000" b="0" i="0">
+                <a:solidFill>
+                  <a:srgbClr val="6B7787"/>
+                </a:solidFill>
+                <a:latin typeface="Calibri"/>
+              </a:rPr>
+              <a:t>Week 5  ·  Prompt Engineering and Large Language Models</a:t>
+            </a:r>
+          </a:p>
+        </p:txBody>
+      </p:sp>
+      <p:sp>
+        <p:nvSpPr>
+          <p:cNvPr id="17" name="TextBox 16"/>
+          <p:cNvSpPr txBox="1"/>
+          <p:nvPr/>
+        </p:nvSpPr>
+        <p:spPr>
+          <a:xfrm>
+            <a:off x="10500055" y="6355080"/>
+            <a:ext cx="914400" cy="274320"/>
+          </a:xfrm>
+          <a:prstGeom prst="rect">
+            <a:avLst/>
+          </a:prstGeom>
+          <a:noFill/>
+        </p:spPr>
+        <p:txBody>
+          <a:bodyPr wrap="square" lIns="0" rIns="0" tIns="0" bIns="0">
+            <a:spAutoFit/>
+          </a:bodyPr>
+          <a:lstStyle/>
+          <a:p>
+            <a:pPr algn="r"/>
+            <a:r>
+              <a:rPr sz="1000" b="0" i="0">
+                <a:solidFill>
+                  <a:srgbClr val="6B7787"/>
+                </a:solidFill>
+                <a:latin typeface="Calibri"/>
+              </a:rPr>
+              <a:t>21</a:t>
+            </a:r>
+          </a:p>
+        </p:txBody>
+      </p:sp>
+    </p:spTree>
+  </p:cSld>
+  <p:clrMapOvr>
+    <a:masterClrMapping/>
+  </p:clrMapOvr>
+</p:sld>
+</file>
+
+<file path=ppt/slides/slide22.xml><?xml version="1.0" encoding="utf-8"?>
+<p:sld xmlns:a="http://schemas.openxmlformats.org/drawingml/2006/main" xmlns:p="http://schemas.openxmlformats.org/presentationml/2006/main" xmlns:r="http://schemas.openxmlformats.org/officeDocument/2006/relationships">
+  <p:cSld>
+    <p:spTree>
+      <p:nvGrpSpPr>
+        <p:cNvPr id="1" name=""/>
+        <p:cNvGrpSpPr/>
+        <p:nvPr/>
+      </p:nvGrpSpPr>
+      <p:grpSpPr/>
+      <p:sp>
+        <p:nvSpPr>
+          <p:cNvPr id="2" name="TextBox 1"/>
+          <p:cNvSpPr txBox="1"/>
+          <p:nvPr/>
+        </p:nvSpPr>
+        <p:spPr>
+          <a:xfrm>
+            <a:off x="777240" y="566928"/>
+            <a:ext cx="10637215" cy="822960"/>
+          </a:xfrm>
+          <a:prstGeom prst="rect">
+            <a:avLst/>
+          </a:prstGeom>
+          <a:noFill/>
+        </p:spPr>
+        <p:txBody>
+          <a:bodyPr wrap="square" lIns="0" rIns="0" tIns="0" bIns="0">
+            <a:spAutoFit/>
+          </a:bodyPr>
+          <a:lstStyle/>
+          <a:p>
+            <a:r>
+              <a:rPr sz="3000" b="1" i="0">
+                <a:solidFill>
+                  <a:srgbClr val="1F2937"/>
+                </a:solidFill>
+                <a:latin typeface="Calibri Light"/>
+              </a:rPr>
+              <a:t>Wrap-Up</a:t>
+            </a:r>
+          </a:p>
+        </p:txBody>
+      </p:sp>
+      <p:sp>
+        <p:nvSpPr>
+          <p:cNvPr id="3" name="Rectangle 2"/>
+          <p:cNvSpPr/>
+          <p:nvPr/>
+        </p:nvSpPr>
+        <p:spPr>
+          <a:xfrm>
+            <a:off x="777240" y="1417320"/>
+            <a:ext cx="1051560" cy="38100"/>
+          </a:xfrm>
+          <a:prstGeom prst="rect">
+            <a:avLst/>
+          </a:prstGeom>
+          <a:solidFill>
+            <a:srgbClr val="0F766E"/>
+          </a:solidFill>
+          <a:ln>
+            <a:noFill/>
+          </a:ln>
+          <a:effectLst/>
+        </p:spPr>
+        <p:style>
+          <a:lnRef idx="1">
+            <a:schemeClr val="accent1"/>
+          </a:lnRef>
+          <a:fillRef idx="3">
+            <a:schemeClr val="accent1"/>
+          </a:fillRef>
+          <a:effectRef idx="2">
+            <a:schemeClr val="accent1"/>
+          </a:effectRef>
+          <a:fontRef idx="minor">
+            <a:schemeClr val="lt1"/>
+          </a:fontRef>
+        </p:style>
+        <p:txBody>
+          <a:bodyPr rtlCol="0" anchor="ctr"/>
+          <a:lstStyle/>
+          <a:p>
+            <a:pPr algn="ctr"/>
+          </a:p>
+        </p:txBody>
+      </p:sp>
+      <p:sp>
+        <p:nvSpPr>
+          <p:cNvPr id="4" name="TextBox 3"/>
+          <p:cNvSpPr txBox="1"/>
+          <p:nvPr/>
+        </p:nvSpPr>
+        <p:spPr>
+          <a:xfrm>
+            <a:off x="777240" y="1783080"/>
+            <a:ext cx="10637215" cy="4343400"/>
+          </a:xfrm>
+          <a:prstGeom prst="rect">
+            <a:avLst/>
+          </a:prstGeom>
+          <a:noFill/>
+        </p:spPr>
+        <p:txBody>
+          <a:bodyPr wrap="square" lIns="0" rIns="0" tIns="0" bIns="0">
+            <a:spAutoFit/>
+          </a:bodyPr>
+          <a:lstStyle/>
+          <a:p>
+            <a:pPr>
+              <a:lnSpc>
+                <a:spcPct val="115000"/>
+              </a:lnSpc>
+              <a:spcAft>
+                <a:spcPts val="1000"/>
+              </a:spcAft>
+            </a:pPr>
+            <a:r>
+              <a:rPr sz="1900" b="0" i="0">
+                <a:solidFill>
+                  <a:srgbClr val="1F2937"/>
+                </a:solidFill>
+                <a:latin typeface="Calibri"/>
+              </a:rPr>
+              <a:t>•  "Professional" describes a feeling, not a text — specify field, tenor and mode instead</a:t>
+            </a:r>
+          </a:p>
+          <a:p>
+            <a:pPr>
+              <a:lnSpc>
+                <a:spcPct val="115000"/>
+              </a:lnSpc>
+              <a:spcAft>
+                <a:spcPts val="1000"/>
+              </a:spcAft>
+            </a:pPr>
+            <a:r>
+              <a:rPr sz="1900" b="0" i="0">
+                <a:solidFill>
+                  <a:srgbClr val="1F2937"/>
+                </a:solidFill>
+                <a:latin typeface="Calibri"/>
+              </a:rPr>
+              <a:t>•  Translate tone adjectives into behaviours you can check</a:t>
+            </a:r>
+          </a:p>
+          <a:p>
+            <a:pPr>
+              <a:lnSpc>
+                <a:spcPct val="115000"/>
+              </a:lnSpc>
+              <a:spcAft>
+                <a:spcPts val="1000"/>
+              </a:spcAft>
+            </a:pPr>
+            <a:r>
+              <a:rPr sz="1900" b="0" i="0">
+                <a:solidFill>
+                  <a:srgbClr val="1F2937"/>
+                </a:solidFill>
+                <a:latin typeface="Calibri"/>
+              </a:rPr>
+              <a:t>•  Reading level is the highest-value style setting in clinical and legal communication</a:t>
+            </a:r>
+          </a:p>
+          <a:p>
+            <a:pPr>
+              <a:lnSpc>
+                <a:spcPct val="115000"/>
+              </a:lnSpc>
+              <a:spcAft>
+                <a:spcPts val="1000"/>
+              </a:spcAft>
+            </a:pPr>
+            <a:r>
+              <a:rPr sz="1900" b="1" i="0">
+                <a:solidFill>
+                  <a:srgbClr val="1F2937"/>
+                </a:solidFill>
+                <a:latin typeface="Calibri"/>
+              </a:rPr>
+              <a:t>•  Always give a fallback — make the honest answer the probable one</a:t>
+            </a:r>
+          </a:p>
+          <a:p>
+            <a:pPr>
+              <a:lnSpc>
+                <a:spcPct val="115000"/>
+              </a:lnSpc>
+              <a:spcAft>
+                <a:spcPts val="1000"/>
+              </a:spcAft>
+            </a:pPr>
+            <a:r>
+              <a:rPr sz="1900" b="0" i="0">
+                <a:solidFill>
+                  <a:srgbClr val="1F2937"/>
+                </a:solidFill>
+                <a:latin typeface="Calibri"/>
+              </a:rPr>
+              <a:t>•  Negative constraints work when they are specific and countable</a:t>
+            </a:r>
+          </a:p>
+          <a:p>
+            <a:pPr>
+              <a:lnSpc>
+                <a:spcPct val="115000"/>
+              </a:lnSpc>
+              <a:spcAft>
+                <a:spcPts val="1000"/>
+              </a:spcAft>
+            </a:pPr>
+          </a:p>
+          <a:p>
+            <a:pPr>
+              <a:lnSpc>
+                <a:spcPct val="115000"/>
+              </a:lnSpc>
+              <a:spcAft>
+                <a:spcPts val="1000"/>
+              </a:spcAft>
+            </a:pPr>
+            <a:r>
+              <a:rPr sz="1900" b="1" i="0">
+                <a:solidFill>
+                  <a:srgbClr val="1F2937"/>
+                </a:solidFill>
+                <a:latin typeface="Calibri"/>
+              </a:rPr>
+              <a:t>•  Next week:</a:t>
+            </a:r>
+          </a:p>
+          <a:p>
+            <a:pPr lvl="1">
+              <a:lnSpc>
+                <a:spcPct val="115000"/>
+              </a:lnSpc>
+              <a:spcAft>
+                <a:spcPts val="500"/>
+              </a:spcAft>
+            </a:pPr>
+            <a:r>
+              <a:rPr sz="1600" b="0" i="0">
+                <a:solidFill>
+                  <a:srgbClr val="333D4B"/>
+                </a:solidFill>
+                <a:latin typeface="Calibri"/>
+              </a:rPr>
+              <a:t>—  Building Your First Tool Without Code — you make something that runs</a:t>
+            </a:r>
+          </a:p>
+        </p:txBody>
+      </p:sp>
+      <p:sp>
+        <p:nvSpPr>
+          <p:cNvPr id="5" name="TextBox 4"/>
+          <p:cNvSpPr txBox="1"/>
+          <p:nvPr/>
+        </p:nvSpPr>
+        <p:spPr>
+          <a:xfrm>
+            <a:off x="777240" y="6355080"/>
+            <a:ext cx="10637215" cy="274320"/>
+          </a:xfrm>
+          <a:prstGeom prst="rect">
+            <a:avLst/>
+          </a:prstGeom>
+          <a:noFill/>
+        </p:spPr>
+        <p:txBody>
+          <a:bodyPr wrap="square" lIns="0" rIns="0" tIns="0" bIns="0">
+            <a:spAutoFit/>
+          </a:bodyPr>
+          <a:lstStyle/>
+          <a:p>
+            <a:r>
+              <a:rPr sz="1000" b="0" i="0">
+                <a:solidFill>
+                  <a:srgbClr val="6B7787"/>
+                </a:solidFill>
+                <a:latin typeface="Calibri"/>
+              </a:rPr>
+              <a:t>Week 5  ·  Prompt Engineering and Large Language Models</a:t>
+            </a:r>
+          </a:p>
+        </p:txBody>
+      </p:sp>
+      <p:sp>
+        <p:nvSpPr>
+          <p:cNvPr id="6" name="TextBox 5"/>
+          <p:cNvSpPr txBox="1"/>
+          <p:nvPr/>
+        </p:nvSpPr>
+        <p:spPr>
+          <a:xfrm>
+            <a:off x="10500055" y="6355080"/>
+            <a:ext cx="914400" cy="274320"/>
+          </a:xfrm>
+          <a:prstGeom prst="rect">
+            <a:avLst/>
+          </a:prstGeom>
+          <a:noFill/>
+        </p:spPr>
+        <p:txBody>
+          <a:bodyPr wrap="square" lIns="0" rIns="0" tIns="0" bIns="0">
+            <a:spAutoFit/>
+          </a:bodyPr>
+          <a:lstStyle/>
+          <a:p>
+            <a:pPr algn="r"/>
+            <a:r>
+              <a:rPr sz="1000" b="0" i="0">
+                <a:solidFill>
+                  <a:srgbClr val="6B7787"/>
+                </a:solidFill>
+                <a:latin typeface="Calibri"/>
+              </a:rPr>
+              <a:t>22</a:t>
+            </a:r>
+          </a:p>
+        </p:txBody>
+      </p:sp>
+    </p:spTree>
+  </p:cSld>
+  <p:clrMapOvr>
+    <a:masterClrMapping/>
+  </p:clrMapOvr>
+</p:sld>
+</file>
+
+<file path=ppt/slides/slide23.xml><?xml version="1.0" encoding="utf-8"?>
 <p:sld xmlns:a="http://schemas.openxmlformats.org/drawingml/2006/main" xmlns:p="http://schemas.openxmlformats.org/presentationml/2006/main" xmlns:r="http://schemas.openxmlformats.org/officeDocument/2006/relationships">
   <p:cSld>
     <p:spTree>

</xml_diff>